<commit_message>
Fix RTL: set table direction on tblPr (not tbl), and order summary cards + dashboard charts right-to-left
</commit_message>
<xml_diff>
--- a/docs/procurement-executive-deck.pptx
+++ b/docs/procurement-executive-deck.pptx
@@ -3650,8 +3650,8 @@
         </p:xfrm>
         <a:graphic>
           <a:graphicData uri="http://schemas.openxmlformats.org/drawingml/2006/table">
-            <a:tbl rtl="1">
-              <a:tblPr firstRow="1" bandRow="1">
+            <a:tbl>
+              <a:tblPr firstRow="1" bandRow="1" rtl="1">
                 <a:tableStyleId>{5C22544A-7EE6-4342-B048-85BDC9FD1C3A}</a:tableStyleId>
               </a:tblPr>
               <a:tblGrid>
@@ -4222,8 +4222,8 @@
         </p:xfrm>
         <a:graphic>
           <a:graphicData uri="http://schemas.openxmlformats.org/drawingml/2006/table">
-            <a:tbl rtl="1">
-              <a:tblPr firstRow="1" bandRow="1">
+            <a:tbl>
+              <a:tblPr firstRow="1" bandRow="1" rtl="1">
                 <a:tableStyleId>{5C22544A-7EE6-4342-B048-85BDC9FD1C3A}</a:tableStyleId>
               </a:tblPr>
               <a:tblGrid>
@@ -4842,8 +4842,8 @@
         </p:xfrm>
         <a:graphic>
           <a:graphicData uri="http://schemas.openxmlformats.org/drawingml/2006/table">
-            <a:tbl rtl="1">
-              <a:tblPr firstRow="1" bandRow="1">
+            <a:tbl>
+              <a:tblPr firstRow="1" bandRow="1" rtl="1">
                 <a:tableStyleId>{5C22544A-7EE6-4342-B048-85BDC9FD1C3A}</a:tableStyleId>
               </a:tblPr>
               <a:tblGrid>
@@ -5414,8 +5414,8 @@
         </p:xfrm>
         <a:graphic>
           <a:graphicData uri="http://schemas.openxmlformats.org/drawingml/2006/table">
-            <a:tbl rtl="1">
-              <a:tblPr firstRow="1" bandRow="1">
+            <a:tbl>
+              <a:tblPr firstRow="1" bandRow="1" rtl="1">
                 <a:tableStyleId>{5C22544A-7EE6-4342-B048-85BDC9FD1C3A}</a:tableStyleId>
               </a:tblPr>
               <a:tblGrid>
@@ -5986,8 +5986,8 @@
         </p:xfrm>
         <a:graphic>
           <a:graphicData uri="http://schemas.openxmlformats.org/drawingml/2006/table">
-            <a:tbl rtl="1">
-              <a:tblPr firstRow="1" bandRow="1">
+            <a:tbl>
+              <a:tblPr firstRow="1" bandRow="1" rtl="1">
                 <a:tableStyleId>{5C22544A-7EE6-4342-B048-85BDC9FD1C3A}</a:tableStyleId>
               </a:tblPr>
               <a:tblGrid>
@@ -10186,8 +10186,8 @@
         </p:xfrm>
         <a:graphic>
           <a:graphicData uri="http://schemas.openxmlformats.org/drawingml/2006/table">
-            <a:tbl rtl="1">
-              <a:tblPr firstRow="1" bandRow="1">
+            <a:tbl>
+              <a:tblPr firstRow="1" bandRow="1" rtl="1">
                 <a:tableStyleId>{5C22544A-7EE6-4342-B048-85BDC9FD1C3A}</a:tableStyleId>
               </a:tblPr>
               <a:tblGrid>
@@ -10781,8 +10781,8 @@
         </p:xfrm>
         <a:graphic>
           <a:graphicData uri="http://schemas.openxmlformats.org/drawingml/2006/table">
-            <a:tbl rtl="1">
-              <a:tblPr firstRow="1" bandRow="1">
+            <a:tbl>
+              <a:tblPr firstRow="1" bandRow="1" rtl="1">
                 <a:tableStyleId>{5C22544A-7EE6-4342-B048-85BDC9FD1C3A}</a:tableStyleId>
               </a:tblPr>
               <a:tblGrid>
@@ -13949,7 +13949,7 @@
                 </a:solidFill>
                 <a:latin typeface="Neo Sans Arabic"/>
               </a:rPr>
-              <a:t>المشاكل ومعالجتها</a:t>
+              <a:t>الوضع والمشاكل</a:t>
             </a:r>
           </a:p>
           <a:p>
@@ -13965,7 +13965,7 @@
                 </a:solidFill>
                 <a:latin typeface="Neo Sans Arabic"/>
               </a:rPr>
-              <a:t>سبعة محاور: كل مشكلة ومعالجتها المقترحة</a:t>
+              <a:t>أرقام النظام، ثم سبعة محاور بمعالجاتها</a:t>
             </a:r>
           </a:p>
         </p:txBody>
@@ -17839,7 +17839,7 @@
         </p:nvSpPr>
         <p:spPr>
           <a:xfrm>
-            <a:off x="457200" y="1463040"/>
+            <a:off x="6187287" y="1463040"/>
             <a:ext cx="5547207" cy="1371600"/>
           </a:xfrm>
           <a:prstGeom prst="rect">
@@ -17885,7 +17885,7 @@
         </p:nvSpPr>
         <p:spPr>
           <a:xfrm>
-            <a:off x="5890107" y="1463040"/>
+            <a:off x="11620195" y="1463040"/>
             <a:ext cx="114300" cy="1371600"/>
           </a:xfrm>
           <a:prstGeom prst="rect">
@@ -17929,7 +17929,7 @@
         </p:nvSpPr>
         <p:spPr>
           <a:xfrm>
-            <a:off x="640080" y="1627632"/>
+            <a:off x="6370167" y="1627632"/>
             <a:ext cx="5090007" cy="1097280"/>
           </a:xfrm>
           <a:prstGeom prst="rect">
@@ -17984,7 +17984,7 @@
         </p:nvSpPr>
         <p:spPr>
           <a:xfrm>
-            <a:off x="6187287" y="1463040"/>
+            <a:off x="457200" y="1463040"/>
             <a:ext cx="5547207" cy="1371600"/>
           </a:xfrm>
           <a:prstGeom prst="rect">
@@ -18030,7 +18030,7 @@
         </p:nvSpPr>
         <p:spPr>
           <a:xfrm>
-            <a:off x="11620195" y="1463040"/>
+            <a:off x="5890107" y="1463040"/>
             <a:ext cx="114300" cy="1371600"/>
           </a:xfrm>
           <a:prstGeom prst="rect">
@@ -18074,7 +18074,7 @@
         </p:nvSpPr>
         <p:spPr>
           <a:xfrm>
-            <a:off x="6370167" y="1627632"/>
+            <a:off x="640080" y="1627632"/>
             <a:ext cx="5090007" cy="1097280"/>
           </a:xfrm>
           <a:prstGeom prst="rect">
@@ -18116,7 +18116,7 @@
                 </a:solidFill>
                 <a:latin typeface="Neo Sans Arabic"/>
               </a:rPr>
-              <a:t>ازدواج إنفاق، وتأخّر توريد، وتآكل ثقة الموردين.</a:t>
+              <a:t>تأخّر 68٪ من الأوامر، وازدواج إنفاق، وتآكل ثقة الموردين.</a:t>
             </a:r>
           </a:p>
         </p:txBody>
@@ -18129,7 +18129,7 @@
         </p:nvSpPr>
         <p:spPr>
           <a:xfrm>
-            <a:off x="457200" y="3017520"/>
+            <a:off x="6187287" y="3017520"/>
             <a:ext cx="5547207" cy="1371600"/>
           </a:xfrm>
           <a:prstGeom prst="rect">
@@ -18175,7 +18175,7 @@
         </p:nvSpPr>
         <p:spPr>
           <a:xfrm>
-            <a:off x="5890107" y="3017520"/>
+            <a:off x="11620195" y="3017520"/>
             <a:ext cx="114300" cy="1371600"/>
           </a:xfrm>
           <a:prstGeom prst="rect">
@@ -18219,7 +18219,7 @@
         </p:nvSpPr>
         <p:spPr>
           <a:xfrm>
-            <a:off x="640080" y="3182112"/>
+            <a:off x="6370167" y="3182112"/>
             <a:ext cx="5090007" cy="1097280"/>
           </a:xfrm>
           <a:prstGeom prst="rect">
@@ -18274,7 +18274,7 @@
         </p:nvSpPr>
         <p:spPr>
           <a:xfrm>
-            <a:off x="6187287" y="3017520"/>
+            <a:off x="457200" y="3017520"/>
             <a:ext cx="5547207" cy="1371600"/>
           </a:xfrm>
           <a:prstGeom prst="rect">
@@ -18320,7 +18320,7 @@
         </p:nvSpPr>
         <p:spPr>
           <a:xfrm>
-            <a:off x="11620195" y="3017520"/>
+            <a:off x="5890107" y="3017520"/>
             <a:ext cx="114300" cy="1371600"/>
           </a:xfrm>
           <a:prstGeom prst="rect">
@@ -18364,7 +18364,7 @@
         </p:nvSpPr>
         <p:spPr>
           <a:xfrm>
-            <a:off x="6370167" y="3182112"/>
+            <a:off x="640080" y="3182112"/>
             <a:ext cx="5090007" cy="1097280"/>
           </a:xfrm>
           <a:prstGeom prst="rect">
@@ -21824,8 +21824,8 @@
         </p:nvSpPr>
         <p:spPr>
           <a:xfrm>
-            <a:off x="6156655" y="1234440"/>
-            <a:ext cx="5760720" cy="365760"/>
+            <a:off x="6355080" y="1234440"/>
+            <a:ext cx="5394960" cy="365760"/>
           </a:xfrm>
           <a:prstGeom prst="rect">
             <a:avLst/>
@@ -21863,7 +21863,7 @@
         </p:nvSpPr>
         <p:spPr>
           <a:xfrm>
-            <a:off x="4480560" y="1764792"/>
+            <a:off x="10012680" y="1764792"/>
             <a:ext cx="1737360" cy="420624"/>
           </a:xfrm>
           <a:prstGeom prst="rect">
@@ -21902,8 +21902,8 @@
         </p:nvSpPr>
         <p:spPr>
           <a:xfrm>
-            <a:off x="457200" y="1783080"/>
-            <a:ext cx="3886200" cy="384048"/>
+            <a:off x="6355080" y="1783080"/>
+            <a:ext cx="3520440" cy="384048"/>
           </a:xfrm>
           <a:prstGeom prst="rect">
             <a:avLst/>
@@ -21946,8 +21946,8 @@
         </p:nvSpPr>
         <p:spPr>
           <a:xfrm>
-            <a:off x="457200" y="1783080"/>
-            <a:ext cx="3886200" cy="384048"/>
+            <a:off x="6355080" y="1783080"/>
+            <a:ext cx="3520440" cy="384048"/>
           </a:xfrm>
           <a:prstGeom prst="rect">
             <a:avLst/>
@@ -21990,8 +21990,8 @@
         </p:nvSpPr>
         <p:spPr>
           <a:xfrm>
-            <a:off x="502920" y="1783080"/>
-            <a:ext cx="3794760" cy="384048"/>
+            <a:off x="6400800" y="1783080"/>
+            <a:ext cx="3429000" cy="384048"/>
           </a:xfrm>
           <a:prstGeom prst="rect">
             <a:avLst/>
@@ -22029,7 +22029,7 @@
         </p:nvSpPr>
         <p:spPr>
           <a:xfrm>
-            <a:off x="4480560" y="2350008"/>
+            <a:off x="10012680" y="2350008"/>
             <a:ext cx="1737360" cy="420624"/>
           </a:xfrm>
           <a:prstGeom prst="rect">
@@ -22068,8 +22068,8 @@
         </p:nvSpPr>
         <p:spPr>
           <a:xfrm>
-            <a:off x="457200" y="2368296"/>
-            <a:ext cx="3886200" cy="384048"/>
+            <a:off x="6355080" y="2368296"/>
+            <a:ext cx="3520440" cy="384048"/>
           </a:xfrm>
           <a:prstGeom prst="rect">
             <a:avLst/>
@@ -22112,8 +22112,8 @@
         </p:nvSpPr>
         <p:spPr>
           <a:xfrm>
-            <a:off x="3627522" y="2368296"/>
-            <a:ext cx="715878" cy="384048"/>
+            <a:off x="9227018" y="2368296"/>
+            <a:ext cx="648502" cy="384048"/>
           </a:xfrm>
           <a:prstGeom prst="rect">
             <a:avLst/>
@@ -22156,8 +22156,8 @@
         </p:nvSpPr>
         <p:spPr>
           <a:xfrm>
-            <a:off x="3673242" y="2368296"/>
-            <a:ext cx="624438" cy="384048"/>
+            <a:off x="9272738" y="2368296"/>
+            <a:ext cx="557062" cy="384048"/>
           </a:xfrm>
           <a:prstGeom prst="rect">
             <a:avLst/>
@@ -22195,7 +22195,7 @@
         </p:nvSpPr>
         <p:spPr>
           <a:xfrm>
-            <a:off x="4480560" y="2935224"/>
+            <a:off x="10012680" y="2935224"/>
             <a:ext cx="1737360" cy="420624"/>
           </a:xfrm>
           <a:prstGeom prst="rect">
@@ -22234,8 +22234,8 @@
         </p:nvSpPr>
         <p:spPr>
           <a:xfrm>
-            <a:off x="457200" y="2953512"/>
-            <a:ext cx="3886200" cy="384048"/>
+            <a:off x="6355080" y="2953512"/>
+            <a:ext cx="3520440" cy="384048"/>
           </a:xfrm>
           <a:prstGeom prst="rect">
             <a:avLst/>
@@ -22278,8 +22278,8 @@
         </p:nvSpPr>
         <p:spPr>
           <a:xfrm>
-            <a:off x="3832058" y="2953512"/>
-            <a:ext cx="511342" cy="384048"/>
+            <a:off x="9412305" y="2953512"/>
+            <a:ext cx="463215" cy="384048"/>
           </a:xfrm>
           <a:prstGeom prst="rect">
             <a:avLst/>
@@ -22322,8 +22322,8 @@
         </p:nvSpPr>
         <p:spPr>
           <a:xfrm>
-            <a:off x="3877778" y="2953512"/>
-            <a:ext cx="419902" cy="384048"/>
+            <a:off x="9458025" y="2953512"/>
+            <a:ext cx="371775" cy="384048"/>
           </a:xfrm>
           <a:prstGeom prst="rect">
             <a:avLst/>
@@ -22361,7 +22361,7 @@
         </p:nvSpPr>
         <p:spPr>
           <a:xfrm>
-            <a:off x="4480560" y="3520440"/>
+            <a:off x="10012680" y="3520440"/>
             <a:ext cx="1737360" cy="420624"/>
           </a:xfrm>
           <a:prstGeom prst="rect">
@@ -22400,8 +22400,8 @@
         </p:nvSpPr>
         <p:spPr>
           <a:xfrm>
-            <a:off x="457200" y="3538728"/>
-            <a:ext cx="3886200" cy="384048"/>
+            <a:off x="6355080" y="3538728"/>
+            <a:ext cx="3520440" cy="384048"/>
           </a:xfrm>
           <a:prstGeom prst="rect">
             <a:avLst/>
@@ -22444,7 +22444,7 @@
         </p:nvSpPr>
         <p:spPr>
           <a:xfrm>
-            <a:off x="3886200" y="3538728"/>
+            <a:off x="9418320" y="3538728"/>
             <a:ext cx="457200" cy="384048"/>
           </a:xfrm>
           <a:prstGeom prst="rect">
@@ -22488,7 +22488,7 @@
         </p:nvSpPr>
         <p:spPr>
           <a:xfrm>
-            <a:off x="3931920" y="3538728"/>
+            <a:off x="9464040" y="3538728"/>
             <a:ext cx="365760" cy="384048"/>
           </a:xfrm>
           <a:prstGeom prst="rect">
@@ -22527,7 +22527,7 @@
         </p:nvSpPr>
         <p:spPr>
           <a:xfrm>
-            <a:off x="4480560" y="4105656"/>
+            <a:off x="10012680" y="4105656"/>
             <a:ext cx="1737360" cy="420624"/>
           </a:xfrm>
           <a:prstGeom prst="rect">
@@ -22566,8 +22566,8 @@
         </p:nvSpPr>
         <p:spPr>
           <a:xfrm>
-            <a:off x="457200" y="4123944"/>
-            <a:ext cx="3886200" cy="384048"/>
+            <a:off x="6355080" y="4123944"/>
+            <a:ext cx="3520440" cy="384048"/>
           </a:xfrm>
           <a:prstGeom prst="rect">
             <a:avLst/>
@@ -22610,7 +22610,7 @@
         </p:nvSpPr>
         <p:spPr>
           <a:xfrm>
-            <a:off x="3886200" y="4123944"/>
+            <a:off x="9418320" y="4123944"/>
             <a:ext cx="457200" cy="384048"/>
           </a:xfrm>
           <a:prstGeom prst="rect">
@@ -22654,7 +22654,7 @@
         </p:nvSpPr>
         <p:spPr>
           <a:xfrm>
-            <a:off x="3931920" y="4123944"/>
+            <a:off x="9464040" y="4123944"/>
             <a:ext cx="365760" cy="384048"/>
           </a:xfrm>
           <a:prstGeom prst="rect">
@@ -22694,7 +22694,7 @@
         <p:spPr>
           <a:xfrm>
             <a:off x="457200" y="1234440"/>
-            <a:ext cx="5486400" cy="365760"/>
+            <a:ext cx="5394960" cy="365760"/>
           </a:xfrm>
           <a:prstGeom prst="rect">
             <a:avLst/>
@@ -22732,7 +22732,7 @@
         </p:nvSpPr>
         <p:spPr>
           <a:xfrm>
-            <a:off x="10287000" y="1764792"/>
+            <a:off x="4389120" y="1764792"/>
             <a:ext cx="1463040" cy="420624"/>
           </a:xfrm>
           <a:prstGeom prst="rect">
@@ -22771,7 +22771,7 @@
         </p:nvSpPr>
         <p:spPr>
           <a:xfrm>
-            <a:off x="6355080" y="1783080"/>
+            <a:off x="457200" y="1783080"/>
             <a:ext cx="3794760" cy="384048"/>
           </a:xfrm>
           <a:prstGeom prst="rect">
@@ -22815,7 +22815,7 @@
         </p:nvSpPr>
         <p:spPr>
           <a:xfrm>
-            <a:off x="6355080" y="1783080"/>
+            <a:off x="457200" y="1783080"/>
             <a:ext cx="3794760" cy="384048"/>
           </a:xfrm>
           <a:prstGeom prst="rect">
@@ -22859,7 +22859,7 @@
         </p:nvSpPr>
         <p:spPr>
           <a:xfrm>
-            <a:off x="6400800" y="1783080"/>
+            <a:off x="502920" y="1783080"/>
             <a:ext cx="3703320" cy="384048"/>
           </a:xfrm>
           <a:prstGeom prst="rect">
@@ -22898,7 +22898,7 @@
         </p:nvSpPr>
         <p:spPr>
           <a:xfrm>
-            <a:off x="10287000" y="2350008"/>
+            <a:off x="4389120" y="2350008"/>
             <a:ext cx="1463040" cy="420624"/>
           </a:xfrm>
           <a:prstGeom prst="rect">
@@ -22937,7 +22937,7 @@
         </p:nvSpPr>
         <p:spPr>
           <a:xfrm>
-            <a:off x="6355080" y="2368296"/>
+            <a:off x="457200" y="2368296"/>
             <a:ext cx="3794760" cy="384048"/>
           </a:xfrm>
           <a:prstGeom prst="rect">
@@ -22981,7 +22981,7 @@
         </p:nvSpPr>
         <p:spPr>
           <a:xfrm>
-            <a:off x="7045037" y="2368296"/>
+            <a:off x="1147157" y="2368296"/>
             <a:ext cx="3104803" cy="384048"/>
           </a:xfrm>
           <a:prstGeom prst="rect">
@@ -23025,7 +23025,7 @@
         </p:nvSpPr>
         <p:spPr>
           <a:xfrm>
-            <a:off x="7090757" y="2368296"/>
+            <a:off x="1192877" y="2368296"/>
             <a:ext cx="3013363" cy="384048"/>
           </a:xfrm>
           <a:prstGeom prst="rect">
@@ -23064,7 +23064,7 @@
         </p:nvSpPr>
         <p:spPr>
           <a:xfrm>
-            <a:off x="10287000" y="2935224"/>
+            <a:off x="4389120" y="2935224"/>
             <a:ext cx="1463040" cy="420624"/>
           </a:xfrm>
           <a:prstGeom prst="rect">
@@ -23103,7 +23103,7 @@
         </p:nvSpPr>
         <p:spPr>
           <a:xfrm>
-            <a:off x="6355080" y="2953512"/>
+            <a:off x="457200" y="2953512"/>
             <a:ext cx="3794760" cy="384048"/>
           </a:xfrm>
           <a:prstGeom prst="rect">
@@ -23147,7 +23147,7 @@
         </p:nvSpPr>
         <p:spPr>
           <a:xfrm>
-            <a:off x="7907482" y="2953512"/>
+            <a:off x="2009602" y="2953512"/>
             <a:ext cx="2242358" cy="384048"/>
           </a:xfrm>
           <a:prstGeom prst="rect">
@@ -23191,7 +23191,7 @@
         </p:nvSpPr>
         <p:spPr>
           <a:xfrm>
-            <a:off x="7953202" y="2953512"/>
+            <a:off x="2055322" y="2953512"/>
             <a:ext cx="2150918" cy="384048"/>
           </a:xfrm>
           <a:prstGeom prst="rect">
@@ -23230,8 +23230,8 @@
         </p:nvSpPr>
         <p:spPr>
           <a:xfrm>
-            <a:off x="6355080" y="3794760"/>
-            <a:ext cx="5394960" cy="1143000"/>
+            <a:off x="457200" y="3657600"/>
+            <a:ext cx="5394960" cy="1234440"/>
           </a:xfrm>
           <a:prstGeom prst="rect">
             <a:avLst/>
@@ -23276,8 +23276,8 @@
         </p:nvSpPr>
         <p:spPr>
           <a:xfrm>
-            <a:off x="6537960" y="3931920"/>
-            <a:ext cx="5029200" cy="914400"/>
+            <a:off x="640080" y="3794760"/>
+            <a:ext cx="5029200" cy="1005840"/>
           </a:xfrm>
           <a:prstGeom prst="rect">
             <a:avLst/>
@@ -23318,7 +23318,7 @@
                 </a:solidFill>
                 <a:latin typeface="Neo Sans Arabic"/>
               </a:rPr>
-              <a:t>من 13 طلباً «عاجلاً»: تأخّر 8 وأُلغي 1 — أي أن صفة العاجل نفسها لا تضمن السرعة.</a:t>
+              <a:t>من 13 طلباً «عاجلاً»: تأخّر 8 وأُلغي 1 — أي أن صفة العاجل لا تضمن السرعة.</a:t>
             </a:r>
           </a:p>
         </p:txBody>
@@ -25568,8 +25568,8 @@
         </p:xfrm>
         <a:graphic>
           <a:graphicData uri="http://schemas.openxmlformats.org/drawingml/2006/table">
-            <a:tbl rtl="1">
-              <a:tblPr firstRow="1" bandRow="1">
+            <a:tbl>
+              <a:tblPr firstRow="1" bandRow="1" rtl="1">
                 <a:tableStyleId>{5C22544A-7EE6-4342-B048-85BDC9FD1C3A}</a:tableStyleId>
               </a:tblPr>
               <a:tblGrid>
@@ -26188,8 +26188,8 @@
         </p:xfrm>
         <a:graphic>
           <a:graphicData uri="http://schemas.openxmlformats.org/drawingml/2006/table">
-            <a:tbl rtl="1">
-              <a:tblPr firstRow="1" bandRow="1">
+            <a:tbl>
+              <a:tblPr firstRow="1" bandRow="1" rtl="1">
                 <a:tableStyleId>{5C22544A-7EE6-4342-B048-85BDC9FD1C3A}</a:tableStyleId>
               </a:tblPr>
               <a:tblGrid>

</xml_diff>

<commit_message>
Update current-state dashboard to live counts (57 POs, 53 suppliers)
</commit_message>
<xml_diff>
--- a/docs/procurement-executive-deck.pptx
+++ b/docs/procurement-executive-deck.pptx
@@ -22954,7 +22954,7 @@
                 </a:solidFill>
                 <a:latin typeface="Neo Sans Arabic"/>
               </a:rPr>
-              <a:t>53</a:t>
+              <a:t>57</a:t>
             </a:r>
           </a:p>
         </p:txBody>
@@ -23009,7 +23009,7 @@
                 </a:solidFill>
                 <a:latin typeface="Neo Sans Arabic"/>
               </a:rPr>
-              <a:t>في السجل</a:t>
+              <a:t>في النظام</a:t>
             </a:r>
           </a:p>
         </p:txBody>
@@ -23075,7 +23075,7 @@
             <a:avLst/>
           </a:prstGeom>
           <a:solidFill>
-            <a:srgbClr val="C9A24B"/>
+            <a:srgbClr val="0E2A38"/>
           </a:solidFill>
           <a:ln>
             <a:noFill/>
@@ -23134,11 +23134,11 @@
             <a:r>
               <a:rPr sz="3400" b="1">
                 <a:solidFill>
-                  <a:srgbClr val="C9A24B"/>
-                </a:solidFill>
-                <a:latin typeface="Neo Sans Arabic"/>
-              </a:rPr>
-              <a:t>405</a:t>
+                  <a:srgbClr val="0E2A38"/>
+                </a:solidFill>
+                <a:latin typeface="Neo Sans Arabic"/>
+              </a:rPr>
+              <a:t>53</a:t>
             </a:r>
           </a:p>
         </p:txBody>
@@ -23177,7 +23177,7 @@
                 </a:solidFill>
                 <a:latin typeface="Neo Sans Arabic"/>
               </a:rPr>
-              <a:t>ألف ريال</a:t>
+              <a:t>مورد معتمد</a:t>
             </a:r>
           </a:p>
           <a:p>
@@ -23193,7 +23193,7 @@
                 </a:solidFill>
                 <a:latin typeface="Neo Sans Arabic"/>
               </a:rPr>
-              <a:t>إجمالي قيمة الأوامر</a:t>
+              <a:t>شركاء نشطون</a:t>
             </a:r>
           </a:p>
         </p:txBody>
@@ -23377,7 +23377,7 @@
                 </a:solidFill>
                 <a:latin typeface="Neo Sans Arabic"/>
               </a:rPr>
-              <a:t>36 من 53</a:t>
+              <a:t>من تحليل سجل الأوامر</a:t>
             </a:r>
           </a:p>
         </p:txBody>
@@ -23627,7 +23627,7 @@
             <a:avLst/>
           </a:prstGeom>
           <a:solidFill>
-            <a:srgbClr val="0E2A38"/>
+            <a:srgbClr val="C57A0C"/>
           </a:solidFill>
           <a:ln>
             <a:noFill/>
@@ -23686,11 +23686,11 @@
             <a:r>
               <a:rPr sz="3400" b="1">
                 <a:solidFill>
-                  <a:srgbClr val="0E2A38"/>
-                </a:solidFill>
-                <a:latin typeface="Neo Sans Arabic"/>
-              </a:rPr>
-              <a:t>42</a:t>
+                  <a:srgbClr val="C57A0C"/>
+                </a:solidFill>
+                <a:latin typeface="Neo Sans Arabic"/>
+              </a:rPr>
+              <a:t>23٪</a:t>
             </a:r>
           </a:p>
         </p:txBody>
@@ -23729,7 +23729,7 @@
                 </a:solidFill>
                 <a:latin typeface="Neo Sans Arabic"/>
               </a:rPr>
-              <a:t>مورد</a:t>
+              <a:t>لم تكتمل</a:t>
             </a:r>
           </a:p>
           <a:p>
@@ -23745,7 +23745,7 @@
                 </a:solidFill>
                 <a:latin typeface="Neo Sans Arabic"/>
               </a:rPr>
-              <a:t>38 مستخدماً فعلياً</a:t>
+              <a:t>ملغاة أو قيد المراجعة</a:t>
             </a:r>
           </a:p>
         </p:txBody>
@@ -23811,7 +23811,7 @@
             <a:avLst/>
           </a:prstGeom>
           <a:solidFill>
-            <a:srgbClr val="C57A0C"/>
+            <a:srgbClr val="C9A24B"/>
           </a:solidFill>
           <a:ln>
             <a:noFill/>
@@ -23870,11 +23870,11 @@
             <a:r>
               <a:rPr sz="3400" b="1">
                 <a:solidFill>
-                  <a:srgbClr val="C57A0C"/>
-                </a:solidFill>
-                <a:latin typeface="Neo Sans Arabic"/>
-              </a:rPr>
-              <a:t>23٪</a:t>
+                  <a:srgbClr val="C9A24B"/>
+                </a:solidFill>
+                <a:latin typeface="Neo Sans Arabic"/>
+              </a:rPr>
+              <a:t>405</a:t>
             </a:r>
           </a:p>
         </p:txBody>
@@ -23913,7 +23913,7 @@
                 </a:solidFill>
                 <a:latin typeface="Neo Sans Arabic"/>
               </a:rPr>
-              <a:t>لم تكتمل</a:t>
+              <a:t>ألف ريال</a:t>
             </a:r>
           </a:p>
           <a:p>
@@ -23929,7 +23929,7 @@
                 </a:solidFill>
                 <a:latin typeface="Neo Sans Arabic"/>
               </a:rPr>
-              <a:t>ملغاة أو قيد المراجعة</a:t>
+              <a:t>إجمالي قيمة الأوامر</a:t>
             </a:r>
           </a:p>
         </p:txBody>

</xml_diff>

<commit_message>
Fix number accuracy for exec meeting: unify PO analysis on 53 (matches status/priority sums), correct finance-caused delays to 39% (14/36), fix page-number total to 24
</commit_message>
<xml_diff>
--- a/docs/procurement-executive-deck.pptx
+++ b/docs/procurement-executive-deck.pptx
@@ -3890,7 +3890,7 @@
                 </a:solidFill>
                 <a:latin typeface="Neo Sans Arabic"/>
               </a:rPr>
-              <a:t>10 / 20</a:t>
+              <a:t>10 / 24</a:t>
             </a:r>
           </a:p>
         </p:txBody>
@@ -5132,7 +5132,7 @@
                 </a:solidFill>
                 <a:latin typeface="Neo Sans Arabic"/>
               </a:rPr>
-              <a:t>11 / 20</a:t>
+              <a:t>11 / 24</a:t>
             </a:r>
           </a:p>
         </p:txBody>
@@ -5752,7 +5752,7 @@
                 </a:solidFill>
                 <a:latin typeface="Neo Sans Arabic"/>
               </a:rPr>
-              <a:t>12 / 20</a:t>
+              <a:t>12 / 24</a:t>
             </a:r>
           </a:p>
         </p:txBody>
@@ -6276,7 +6276,7 @@
                 </a:solidFill>
                 <a:latin typeface="Neo Sans Arabic"/>
               </a:rPr>
-              <a:t>13 / 20</a:t>
+              <a:t>13 / 24</a:t>
             </a:r>
           </a:p>
         </p:txBody>
@@ -6848,7 +6848,7 @@
                 </a:solidFill>
                 <a:latin typeface="Neo Sans Arabic"/>
               </a:rPr>
-              <a:t>14 / 20</a:t>
+              <a:t>14 / 24</a:t>
             </a:r>
           </a:p>
         </p:txBody>
@@ -7372,7 +7372,7 @@
                 </a:solidFill>
                 <a:latin typeface="Neo Sans Arabic"/>
               </a:rPr>
-              <a:t>15 / 20</a:t>
+              <a:t>15 / 24</a:t>
             </a:r>
           </a:p>
         </p:txBody>
@@ -9418,7 +9418,7 @@
                 </a:solidFill>
                 <a:latin typeface="Neo Sans Arabic"/>
               </a:rPr>
-              <a:t>16 / 20</a:t>
+              <a:t>16 / 24</a:t>
             </a:r>
           </a:p>
         </p:txBody>
@@ -10843,7 +10843,7 @@
                 </a:solidFill>
                 <a:latin typeface="Neo Sans Arabic"/>
               </a:rPr>
-              <a:t>17 / 20</a:t>
+              <a:t>17 / 24</a:t>
             </a:r>
           </a:p>
         </p:txBody>
@@ -12023,7 +12023,7 @@
                 </a:solidFill>
                 <a:latin typeface="Neo Sans Arabic"/>
               </a:rPr>
-              <a:t>18 / 20</a:t>
+              <a:t>18 / 24</a:t>
             </a:r>
           </a:p>
         </p:txBody>
@@ -13187,7 +13187,7 @@
                 </a:solidFill>
                 <a:latin typeface="Neo Sans Arabic"/>
               </a:rPr>
-              <a:t>19 / 20</a:t>
+              <a:t>19 / 24</a:t>
             </a:r>
           </a:p>
         </p:txBody>
@@ -14045,7 +14045,7 @@
                 </a:solidFill>
                 <a:latin typeface="Neo Sans Arabic"/>
               </a:rPr>
-              <a:t>2 / 20</a:t>
+              <a:t>2 / 24</a:t>
             </a:r>
           </a:p>
         </p:txBody>
@@ -15221,7 +15221,7 @@
                 </a:solidFill>
                 <a:latin typeface="Neo Sans Arabic"/>
               </a:rPr>
-              <a:t>20 / 20</a:t>
+              <a:t>20 / 24</a:t>
             </a:r>
           </a:p>
         </p:txBody>
@@ -16175,7 +16175,7 @@
                 </a:solidFill>
                 <a:latin typeface="Neo Sans Arabic"/>
               </a:rPr>
-              <a:t>21 / 20</a:t>
+              <a:t>21 / 24</a:t>
             </a:r>
           </a:p>
         </p:txBody>
@@ -17182,7 +17182,7 @@
                 </a:solidFill>
                 <a:latin typeface="Neo Sans Arabic"/>
               </a:rPr>
-              <a:t>44٪</a:t>
+              <a:t>39٪</a:t>
             </a:r>
           </a:p>
         </p:txBody>
@@ -18149,7 +18149,7 @@
                 </a:solidFill>
                 <a:latin typeface="Neo Sans Arabic"/>
               </a:rPr>
-              <a:t>22 / 20</a:t>
+              <a:t>22 / 24</a:t>
             </a:r>
           </a:p>
         </p:txBody>
@@ -19799,7 +19799,7 @@
                 </a:solidFill>
                 <a:latin typeface="Neo Sans Arabic"/>
               </a:rPr>
-              <a:t>23 / 20</a:t>
+              <a:t>23 / 24</a:t>
             </a:r>
           </a:p>
         </p:txBody>
@@ -20908,7 +20908,7 @@
                 </a:solidFill>
                 <a:latin typeface="Neo Sans Arabic"/>
               </a:rPr>
-              <a:t>3 / 20</a:t>
+              <a:t>3 / 24</a:t>
             </a:r>
           </a:p>
         </p:txBody>
@@ -22558,7 +22558,7 @@
                 </a:solidFill>
                 <a:latin typeface="Neo Sans Arabic"/>
               </a:rPr>
-              <a:t>4 / 20</a:t>
+              <a:t>4 / 24</a:t>
             </a:r>
           </a:p>
         </p:txBody>
@@ -22954,7 +22954,7 @@
                 </a:solidFill>
                 <a:latin typeface="Neo Sans Arabic"/>
               </a:rPr>
-              <a:t>57</a:t>
+              <a:t>53</a:t>
             </a:r>
           </a:p>
         </p:txBody>
@@ -23009,7 +23009,7 @@
                 </a:solidFill>
                 <a:latin typeface="Neo Sans Arabic"/>
               </a:rPr>
-              <a:t>في النظام</a:t>
+              <a:t>سجل الأوامر المُحلَّل</a:t>
             </a:r>
           </a:p>
         </p:txBody>
@@ -23075,7 +23075,7 @@
             <a:avLst/>
           </a:prstGeom>
           <a:solidFill>
-            <a:srgbClr val="0E2A38"/>
+            <a:srgbClr val="9E2B25"/>
           </a:solidFill>
           <a:ln>
             <a:noFill/>
@@ -23134,11 +23134,11 @@
             <a:r>
               <a:rPr sz="3400" b="1">
                 <a:solidFill>
-                  <a:srgbClr val="0E2A38"/>
-                </a:solidFill>
-                <a:latin typeface="Neo Sans Arabic"/>
-              </a:rPr>
-              <a:t>53</a:t>
+                  <a:srgbClr val="9E2B25"/>
+                </a:solidFill>
+                <a:latin typeface="Neo Sans Arabic"/>
+              </a:rPr>
+              <a:t>68٪</a:t>
             </a:r>
           </a:p>
         </p:txBody>
@@ -23177,7 +23177,7 @@
                 </a:solidFill>
                 <a:latin typeface="Neo Sans Arabic"/>
               </a:rPr>
-              <a:t>مورد معتمد</a:t>
+              <a:t>طلبات متأخرة</a:t>
             </a:r>
           </a:p>
           <a:p>
@@ -23193,7 +23193,7 @@
                 </a:solidFill>
                 <a:latin typeface="Neo Sans Arabic"/>
               </a:rPr>
-              <a:t>شركاء نشطون</a:t>
+              <a:t>36 من 53</a:t>
             </a:r>
           </a:p>
         </p:txBody>
@@ -23322,7 +23322,7 @@
                 </a:solidFill>
                 <a:latin typeface="Neo Sans Arabic"/>
               </a:rPr>
-              <a:t>68٪</a:t>
+              <a:t>19</a:t>
             </a:r>
           </a:p>
         </p:txBody>
@@ -23361,7 +23361,7 @@
                 </a:solidFill>
                 <a:latin typeface="Neo Sans Arabic"/>
               </a:rPr>
-              <a:t>طلبات متأخرة</a:t>
+              <a:t>يوم متوسط التأخير</a:t>
             </a:r>
           </a:p>
           <a:p>
@@ -23377,7 +23377,7 @@
                 </a:solidFill>
                 <a:latin typeface="Neo Sans Arabic"/>
               </a:rPr>
-              <a:t>من تحليل سجل الأوامر</a:t>
+              <a:t>أقصى تأخير 52 يوماً</a:t>
             </a:r>
           </a:p>
         </p:txBody>
@@ -23443,7 +23443,7 @@
             <a:avLst/>
           </a:prstGeom>
           <a:solidFill>
-            <a:srgbClr val="9E2B25"/>
+            <a:srgbClr val="C57A0C"/>
           </a:solidFill>
           <a:ln>
             <a:noFill/>
@@ -23502,11 +23502,11 @@
             <a:r>
               <a:rPr sz="3400" b="1">
                 <a:solidFill>
-                  <a:srgbClr val="9E2B25"/>
-                </a:solidFill>
-                <a:latin typeface="Neo Sans Arabic"/>
-              </a:rPr>
-              <a:t>19</a:t>
+                  <a:srgbClr val="C57A0C"/>
+                </a:solidFill>
+                <a:latin typeface="Neo Sans Arabic"/>
+              </a:rPr>
+              <a:t>23٪</a:t>
             </a:r>
           </a:p>
         </p:txBody>
@@ -23545,7 +23545,7 @@
                 </a:solidFill>
                 <a:latin typeface="Neo Sans Arabic"/>
               </a:rPr>
-              <a:t>يوم متوسط التأخير</a:t>
+              <a:t>لم تكتمل</a:t>
             </a:r>
           </a:p>
           <a:p>
@@ -23561,7 +23561,7 @@
                 </a:solidFill>
                 <a:latin typeface="Neo Sans Arabic"/>
               </a:rPr>
-              <a:t>أقصى تأخير 52 يوماً</a:t>
+              <a:t>12 طلباً ملغى/قيد المراجعة</a:t>
             </a:r>
           </a:p>
         </p:txBody>
@@ -23627,7 +23627,7 @@
             <a:avLst/>
           </a:prstGeom>
           <a:solidFill>
-            <a:srgbClr val="C57A0C"/>
+            <a:srgbClr val="9E2B25"/>
           </a:solidFill>
           <a:ln>
             <a:noFill/>
@@ -23686,11 +23686,11 @@
             <a:r>
               <a:rPr sz="3400" b="1">
                 <a:solidFill>
-                  <a:srgbClr val="C57A0C"/>
-                </a:solidFill>
-                <a:latin typeface="Neo Sans Arabic"/>
-              </a:rPr>
-              <a:t>23٪</a:t>
+                  <a:srgbClr val="9E2B25"/>
+                </a:solidFill>
+                <a:latin typeface="Neo Sans Arabic"/>
+              </a:rPr>
+              <a:t>39٪</a:t>
             </a:r>
           </a:p>
         </p:txBody>
@@ -23729,7 +23729,7 @@
                 </a:solidFill>
                 <a:latin typeface="Neo Sans Arabic"/>
               </a:rPr>
-              <a:t>لم تكتمل</a:t>
+              <a:t>تأخيرها بسبب المالية</a:t>
             </a:r>
           </a:p>
           <a:p>
@@ -23745,7 +23745,7 @@
                 </a:solidFill>
                 <a:latin typeface="Neo Sans Arabic"/>
               </a:rPr>
-              <a:t>ملغاة أو قيد المراجعة</a:t>
+              <a:t>14 من 36 متأخراً</a:t>
             </a:r>
           </a:p>
         </p:txBody>
@@ -24007,7 +24007,7 @@
                 </a:solidFill>
                 <a:latin typeface="Neo Sans Arabic"/>
               </a:rPr>
-              <a:t>5 / 20</a:t>
+              <a:t>5 / 24</a:t>
             </a:r>
           </a:p>
         </p:txBody>
@@ -26002,7 +26002,7 @@
                 </a:solidFill>
                 <a:latin typeface="Neo Sans Arabic"/>
               </a:rPr>
-              <a:t>6 / 20</a:t>
+              <a:t>6 / 24</a:t>
             </a:r>
           </a:p>
         </p:txBody>
@@ -26398,7 +26398,7 @@
                 </a:solidFill>
                 <a:latin typeface="Neo Sans Arabic"/>
               </a:rPr>
-              <a:t>44٪</a:t>
+              <a:t>39٪</a:t>
             </a:r>
           </a:p>
         </p:txBody>
@@ -26453,7 +26453,7 @@
                 </a:solidFill>
                 <a:latin typeface="Neo Sans Arabic"/>
               </a:rPr>
-              <a:t>سببها التحويل المالي</a:t>
+              <a:t>سببها التحويل المالي (14 من 36)</a:t>
             </a:r>
           </a:p>
         </p:txBody>
@@ -27745,7 +27745,7 @@
                 </a:solidFill>
                 <a:latin typeface="Neo Sans Arabic"/>
               </a:rPr>
-              <a:t>7 / 20</a:t>
+              <a:t>7 / 24</a:t>
             </a:r>
           </a:p>
         </p:txBody>
@@ -28365,7 +28365,7 @@
                 </a:solidFill>
                 <a:latin typeface="Neo Sans Arabic"/>
               </a:rPr>
-              <a:t>8 / 20</a:t>
+              <a:t>8 / 24</a:t>
             </a:r>
           </a:p>
         </p:txBody>
@@ -28937,7 +28937,7 @@
                 </a:solidFill>
                 <a:latin typeface="Neo Sans Arabic"/>
               </a:rPr>
-              <a:t>9 / 20</a:t>
+              <a:t>9 / 24</a:t>
             </a:r>
           </a:p>
         </p:txBody>

</xml_diff>

<commit_message>
Rebuild current-state dashboards on live system data (57 POs): 42 delivered/10 at finance/5 cancelled, 8 delayed (15.4%, avg 20.4d, max 59), 26.2% on-time, 351K value, delay-aging chart, sector counts; update KPIs and impact to live baselines
</commit_message>
<xml_diff>
--- a/docs/procurement-executive-deck.pptx
+++ b/docs/procurement-executive-deck.pptx
@@ -16571,7 +16571,7 @@
                 </a:solidFill>
                 <a:latin typeface="Neo Sans Arabic"/>
               </a:rPr>
-              <a:t>الطلبات المتأخرة</a:t>
+              <a:t>التسليم في الموعد</a:t>
             </a:r>
           </a:p>
         </p:txBody>
@@ -16626,7 +16626,7 @@
                 </a:solidFill>
                 <a:latin typeface="Neo Sans Arabic"/>
               </a:rPr>
-              <a:t>68٪</a:t>
+              <a:t>26.2٪</a:t>
             </a:r>
           </a:p>
         </p:txBody>
@@ -16681,7 +16681,7 @@
                 </a:solidFill>
                 <a:latin typeface="Neo Sans Arabic"/>
               </a:rPr>
-              <a:t>أقل من 15٪</a:t>
+              <a:t>90٪ فأكثر</a:t>
             </a:r>
           </a:p>
         </p:txBody>
@@ -16849,7 +16849,7 @@
                 </a:solidFill>
                 <a:latin typeface="Neo Sans Arabic"/>
               </a:rPr>
-              <a:t>متوسط زمن التوريد</a:t>
+              <a:t>الأوامر المتأخرة</a:t>
             </a:r>
           </a:p>
         </p:txBody>
@@ -16904,7 +16904,7 @@
                 </a:solidFill>
                 <a:latin typeface="Neo Sans Arabic"/>
               </a:rPr>
-              <a:t>15.6 يوم</a:t>
+              <a:t>15.4٪</a:t>
             </a:r>
           </a:p>
         </p:txBody>
@@ -16959,7 +16959,7 @@
                 </a:solidFill>
                 <a:latin typeface="Neo Sans Arabic"/>
               </a:rPr>
-              <a:t>8 أيام</a:t>
+              <a:t>أقل من 5٪</a:t>
             </a:r>
           </a:p>
         </p:txBody>
@@ -17127,7 +17127,7 @@
                 </a:solidFill>
                 <a:latin typeface="Neo Sans Arabic"/>
               </a:rPr>
-              <a:t>تأخيرات بسبب المالية</a:t>
+              <a:t>متوسط أيام التأخير</a:t>
             </a:r>
           </a:p>
         </p:txBody>
@@ -17182,7 +17182,7 @@
                 </a:solidFill>
                 <a:latin typeface="Neo Sans Arabic"/>
               </a:rPr>
-              <a:t>39٪</a:t>
+              <a:t>20.4 يوم</a:t>
             </a:r>
           </a:p>
         </p:txBody>
@@ -17237,7 +17237,7 @@
                 </a:solidFill>
                 <a:latin typeface="Neo Sans Arabic"/>
               </a:rPr>
-              <a:t>أقل من 10٪</a:t>
+              <a:t>أقل من 5 أيام</a:t>
             </a:r>
           </a:p>
         </p:txBody>
@@ -17405,7 +17405,7 @@
                 </a:solidFill>
                 <a:latin typeface="Neo Sans Arabic"/>
               </a:rPr>
-              <a:t>الطلبات غير المكتملة</a:t>
+              <a:t>أوامر عالقة لدى المالية</a:t>
             </a:r>
           </a:p>
         </p:txBody>
@@ -17460,7 +17460,7 @@
                 </a:solidFill>
                 <a:latin typeface="Neo Sans Arabic"/>
               </a:rPr>
-              <a:t>23٪</a:t>
+              <a:t>10 أوامر</a:t>
             </a:r>
           </a:p>
         </p:txBody>
@@ -17515,7 +17515,7 @@
                 </a:solidFill>
                 <a:latin typeface="Neo Sans Arabic"/>
               </a:rPr>
-              <a:t>أقل من 5٪</a:t>
+              <a:t>إلى الصفر</a:t>
             </a:r>
           </a:p>
         </p:txBody>
@@ -17683,7 +17683,7 @@
                 </a:solidFill>
                 <a:latin typeface="Neo Sans Arabic"/>
               </a:rPr>
-              <a:t>الالتزام بالعروض الثلاثة</a:t>
+              <a:t>مؤشر صحة النظام</a:t>
             </a:r>
           </a:p>
         </p:txBody>
@@ -17738,7 +17738,7 @@
                 </a:solidFill>
                 <a:latin typeface="Neo Sans Arabic"/>
               </a:rPr>
-              <a:t>يُبدأ القياس</a:t>
+              <a:t>42٪</a:t>
             </a:r>
           </a:p>
         </p:txBody>
@@ -17793,7 +17793,7 @@
                 </a:solidFill>
                 <a:latin typeface="Neo Sans Arabic"/>
               </a:rPr>
-              <a:t>95٪ فأكثر</a:t>
+              <a:t>85٪ فأكثر</a:t>
             </a:r>
           </a:p>
         </p:txBody>
@@ -17961,7 +17961,7 @@
                 </a:solidFill>
                 <a:latin typeface="Neo Sans Arabic"/>
               </a:rPr>
-              <a:t>الموردون المسجّلون</a:t>
+              <a:t>الالتزام بالعروض الثلاثة</a:t>
             </a:r>
           </a:p>
         </p:txBody>
@@ -18016,7 +18016,7 @@
                 </a:solidFill>
                 <a:latin typeface="Neo Sans Arabic"/>
               </a:rPr>
-              <a:t>53 مورداً</a:t>
+              <a:t>يُبدأ القياس</a:t>
             </a:r>
           </a:p>
         </p:txBody>
@@ -18071,7 +18071,7 @@
                 </a:solidFill>
                 <a:latin typeface="Neo Sans Arabic"/>
               </a:rPr>
-              <a:t>نموّ مستمر</a:t>
+              <a:t>95٪ فأكثر</a:t>
             </a:r>
           </a:p>
         </p:txBody>
@@ -20579,7 +20579,7 @@
                 </a:solidFill>
                 <a:latin typeface="Neo Sans Arabic"/>
               </a:rPr>
-              <a:t>تأخّر 68٪ من الأوامر، وازدواج إنفاق، وتآكل ثقة الموردين.</a:t>
+              <a:t>تأخّر تسليم 74٪ من الأوامر، و10 عالقة لدى المالية، وتآكل ثقة الموردين.</a:t>
             </a:r>
           </a:p>
         </p:txBody>
@@ -22954,7 +22954,7 @@
                 </a:solidFill>
                 <a:latin typeface="Neo Sans Arabic"/>
               </a:rPr>
-              <a:t>53</a:t>
+              <a:t>57</a:t>
             </a:r>
           </a:p>
         </p:txBody>
@@ -23009,7 +23009,7 @@
                 </a:solidFill>
                 <a:latin typeface="Neo Sans Arabic"/>
               </a:rPr>
-              <a:t>سجل الأوامر المُحلَّل</a:t>
+              <a:t>52 نشطاً · 5 ملغاة</a:t>
             </a:r>
           </a:p>
         </p:txBody>
@@ -23075,7 +23075,7 @@
             <a:avLst/>
           </a:prstGeom>
           <a:solidFill>
-            <a:srgbClr val="9E2B25"/>
+            <a:srgbClr val="C9A24B"/>
           </a:solidFill>
           <a:ln>
             <a:noFill/>
@@ -23134,11 +23134,11 @@
             <a:r>
               <a:rPr sz="3400" b="1">
                 <a:solidFill>
-                  <a:srgbClr val="9E2B25"/>
-                </a:solidFill>
-                <a:latin typeface="Neo Sans Arabic"/>
-              </a:rPr>
-              <a:t>68٪</a:t>
+                  <a:srgbClr val="C9A24B"/>
+                </a:solidFill>
+                <a:latin typeface="Neo Sans Arabic"/>
+              </a:rPr>
+              <a:t>351</a:t>
             </a:r>
           </a:p>
         </p:txBody>
@@ -23177,7 +23177,7 @@
                 </a:solidFill>
                 <a:latin typeface="Neo Sans Arabic"/>
               </a:rPr>
-              <a:t>طلبات متأخرة</a:t>
+              <a:t>ألف ريال</a:t>
             </a:r>
           </a:p>
           <a:p>
@@ -23193,7 +23193,7 @@
                 </a:solidFill>
                 <a:latin typeface="Neo Sans Arabic"/>
               </a:rPr>
-              <a:t>36 من 53</a:t>
+              <a:t>قيمة المشتريات الفعلية</a:t>
             </a:r>
           </a:p>
         </p:txBody>
@@ -23322,7 +23322,7 @@
                 </a:solidFill>
                 <a:latin typeface="Neo Sans Arabic"/>
               </a:rPr>
-              <a:t>19</a:t>
+              <a:t>8</a:t>
             </a:r>
           </a:p>
         </p:txBody>
@@ -23361,7 +23361,7 @@
                 </a:solidFill>
                 <a:latin typeface="Neo Sans Arabic"/>
               </a:rPr>
-              <a:t>يوم متوسط التأخير</a:t>
+              <a:t>أوامر متأخرة</a:t>
             </a:r>
           </a:p>
           <a:p>
@@ -23377,7 +23377,7 @@
                 </a:solidFill>
                 <a:latin typeface="Neo Sans Arabic"/>
               </a:rPr>
-              <a:t>أقصى تأخير 52 يوماً</a:t>
+              <a:t>15.4٪ من النشطة</a:t>
             </a:r>
           </a:p>
         </p:txBody>
@@ -23443,7 +23443,7 @@
             <a:avLst/>
           </a:prstGeom>
           <a:solidFill>
-            <a:srgbClr val="C57A0C"/>
+            <a:srgbClr val="9E2B25"/>
           </a:solidFill>
           <a:ln>
             <a:noFill/>
@@ -23502,11 +23502,11 @@
             <a:r>
               <a:rPr sz="3400" b="1">
                 <a:solidFill>
-                  <a:srgbClr val="C57A0C"/>
-                </a:solidFill>
-                <a:latin typeface="Neo Sans Arabic"/>
-              </a:rPr>
-              <a:t>23٪</a:t>
+                  <a:srgbClr val="9E2B25"/>
+                </a:solidFill>
+                <a:latin typeface="Neo Sans Arabic"/>
+              </a:rPr>
+              <a:t>20.4</a:t>
             </a:r>
           </a:p>
         </p:txBody>
@@ -23545,7 +23545,7 @@
                 </a:solidFill>
                 <a:latin typeface="Neo Sans Arabic"/>
               </a:rPr>
-              <a:t>لم تكتمل</a:t>
+              <a:t>يوم متوسط التأخير</a:t>
             </a:r>
           </a:p>
           <a:p>
@@ -23561,7 +23561,7 @@
                 </a:solidFill>
                 <a:latin typeface="Neo Sans Arabic"/>
               </a:rPr>
-              <a:t>12 طلباً ملغى/قيد المراجعة</a:t>
+              <a:t>أقصى 59 يوماً</a:t>
             </a:r>
           </a:p>
         </p:txBody>
@@ -23627,7 +23627,7 @@
             <a:avLst/>
           </a:prstGeom>
           <a:solidFill>
-            <a:srgbClr val="9E2B25"/>
+            <a:srgbClr val="C57A0C"/>
           </a:solidFill>
           <a:ln>
             <a:noFill/>
@@ -23686,11 +23686,11 @@
             <a:r>
               <a:rPr sz="3400" b="1">
                 <a:solidFill>
-                  <a:srgbClr val="9E2B25"/>
-                </a:solidFill>
-                <a:latin typeface="Neo Sans Arabic"/>
-              </a:rPr>
-              <a:t>39٪</a:t>
+                  <a:srgbClr val="C57A0C"/>
+                </a:solidFill>
+                <a:latin typeface="Neo Sans Arabic"/>
+              </a:rPr>
+              <a:t>10</a:t>
             </a:r>
           </a:p>
         </p:txBody>
@@ -23729,7 +23729,7 @@
                 </a:solidFill>
                 <a:latin typeface="Neo Sans Arabic"/>
               </a:rPr>
-              <a:t>تأخيرها بسبب المالية</a:t>
+              <a:t>عالقة لدى المالية</a:t>
             </a:r>
           </a:p>
           <a:p>
@@ -23745,7 +23745,7 @@
                 </a:solidFill>
                 <a:latin typeface="Neo Sans Arabic"/>
               </a:rPr>
-              <a:t>14 من 36 متأخراً</a:t>
+              <a:t>بانتظار التحويل</a:t>
             </a:r>
           </a:p>
         </p:txBody>
@@ -23811,7 +23811,7 @@
             <a:avLst/>
           </a:prstGeom>
           <a:solidFill>
-            <a:srgbClr val="C9A24B"/>
+            <a:srgbClr val="9E2B25"/>
           </a:solidFill>
           <a:ln>
             <a:noFill/>
@@ -23870,11 +23870,11 @@
             <a:r>
               <a:rPr sz="3400" b="1">
                 <a:solidFill>
-                  <a:srgbClr val="C9A24B"/>
-                </a:solidFill>
-                <a:latin typeface="Neo Sans Arabic"/>
-              </a:rPr>
-              <a:t>405</a:t>
+                  <a:srgbClr val="9E2B25"/>
+                </a:solidFill>
+                <a:latin typeface="Neo Sans Arabic"/>
+              </a:rPr>
+              <a:t>26.2٪</a:t>
             </a:r>
           </a:p>
         </p:txBody>
@@ -23913,7 +23913,7 @@
                 </a:solidFill>
                 <a:latin typeface="Neo Sans Arabic"/>
               </a:rPr>
-              <a:t>ألف ريال</a:t>
+              <a:t>سُلّمت في موعدها</a:t>
             </a:r>
           </a:p>
           <a:p>
@@ -23929,7 +23929,7 @@
                 </a:solidFill>
                 <a:latin typeface="Neo Sans Arabic"/>
               </a:rPr>
-              <a:t>إجمالي قيمة الأوامر</a:t>
+              <a:t>11 من 42 مُسلَّماً</a:t>
             </a:r>
           </a:p>
         </p:txBody>
@@ -23968,7 +23968,7 @@
                 </a:solidFill>
                 <a:latin typeface="Neo Sans Arabic"/>
               </a:rPr>
-              <a:t>المصدر: نظام المشتريات — سجل أوامر الشراء (53 أمراً)</a:t>
+              <a:t>المصدر: نظام المشتريات — سجل أوامر الشراء (57 أمراً)</a:t>
             </a:r>
           </a:p>
         </p:txBody>
@@ -24196,7 +24196,7 @@
                 </a:solidFill>
                 <a:latin typeface="Neo Sans Arabic"/>
               </a:rPr>
-              <a:t>لوحة حالة الأوامر والأولوية</a:t>
+              <a:t>لوحة حالة الأوامر والتأخير</a:t>
             </a:r>
           </a:p>
         </p:txBody>
@@ -24352,7 +24352,7 @@
                 </a:solidFill>
                 <a:latin typeface="Neo Sans Arabic"/>
               </a:rPr>
-              <a:t>مُسلَّم</a:t>
+              <a:t>مُسلَّم كامل</a:t>
             </a:r>
           </a:p>
         </p:txBody>
@@ -24479,7 +24479,7 @@
                 </a:solidFill>
                 <a:latin typeface="Neo Sans Arabic"/>
               </a:rPr>
-              <a:t>38</a:t>
+              <a:t>42</a:t>
             </a:r>
           </a:p>
         </p:txBody>
@@ -24518,7 +24518,7 @@
                 </a:solidFill>
                 <a:latin typeface="Neo Sans Arabic"/>
               </a:rPr>
-              <a:t>قيد المراجعة</a:t>
+              <a:t>لدى المالية</a:t>
             </a:r>
           </a:p>
         </p:txBody>
@@ -24575,8 +24575,8 @@
         </p:nvSpPr>
         <p:spPr>
           <a:xfrm>
-            <a:off x="9227018" y="2368296"/>
-            <a:ext cx="648502" cy="384048"/>
+            <a:off x="9037320" y="2368296"/>
+            <a:ext cx="838200" cy="384048"/>
           </a:xfrm>
           <a:prstGeom prst="rect">
             <a:avLst/>
@@ -24619,8 +24619,8 @@
         </p:nvSpPr>
         <p:spPr>
           <a:xfrm>
-            <a:off x="9272738" y="2368296"/>
-            <a:ext cx="557062" cy="384048"/>
+            <a:off x="9083040" y="2368296"/>
+            <a:ext cx="746760" cy="384048"/>
           </a:xfrm>
           <a:prstGeom prst="rect">
             <a:avLst/>
@@ -24645,7 +24645,7 @@
                 </a:solidFill>
                 <a:latin typeface="Neo Sans Arabic"/>
               </a:rPr>
-              <a:t>7</a:t>
+              <a:t>10</a:t>
             </a:r>
           </a:p>
         </p:txBody>
@@ -24741,8 +24741,8 @@
         </p:nvSpPr>
         <p:spPr>
           <a:xfrm>
-            <a:off x="9412305" y="2953512"/>
-            <a:ext cx="463215" cy="384048"/>
+            <a:off x="9418320" y="2953512"/>
+            <a:ext cx="457200" cy="384048"/>
           </a:xfrm>
           <a:prstGeom prst="rect">
             <a:avLst/>
@@ -24785,8 +24785,8 @@
         </p:nvSpPr>
         <p:spPr>
           <a:xfrm>
-            <a:off x="9458025" y="2953512"/>
-            <a:ext cx="371775" cy="384048"/>
+            <a:off x="9464040" y="2953512"/>
+            <a:ext cx="365760" cy="384048"/>
           </a:xfrm>
           <a:prstGeom prst="rect">
             <a:avLst/>
@@ -24824,8 +24824,47 @@
         </p:nvSpPr>
         <p:spPr>
           <a:xfrm>
-            <a:off x="10012680" y="3520440"/>
-            <a:ext cx="1737360" cy="420624"/>
+            <a:off x="457200" y="1234440"/>
+            <a:ext cx="5394960" cy="365760"/>
+          </a:xfrm>
+          <a:prstGeom prst="rect">
+            <a:avLst/>
+          </a:prstGeom>
+          <a:noFill/>
+        </p:spPr>
+        <p:txBody>
+          <a:bodyPr wrap="square" anchor="t" lIns="76200" rIns="76200" tIns="38100" bIns="38100">
+            <a:spAutoFit/>
+          </a:bodyPr>
+          <a:lstStyle/>
+          <a:p>
+            <a:pPr rtl="1" algn="r">
+              <a:spcAft>
+                <a:spcPts val="600"/>
+              </a:spcAft>
+            </a:pPr>
+            <a:r>
+              <a:rPr sz="1600" b="1">
+                <a:solidFill>
+                  <a:srgbClr val="C9A24B"/>
+                </a:solidFill>
+                <a:latin typeface="Neo Sans Arabic"/>
+              </a:rPr>
+              <a:t>تقادم الأوامر المتأخرة (8)</a:t>
+            </a:r>
+          </a:p>
+        </p:txBody>
+      </p:sp>
+      <p:sp>
+        <p:nvSpPr>
+          <p:cNvPr id="22" name="TextBox 21"/>
+          <p:cNvSpPr txBox="1"/>
+          <p:nvPr/>
+        </p:nvSpPr>
+        <p:spPr>
+          <a:xfrm>
+            <a:off x="3931920" y="1764792"/>
+            <a:ext cx="1920240" cy="420624"/>
           </a:xfrm>
           <a:prstGeom prst="rect">
             <a:avLst/>
@@ -24850,21 +24889,21 @@
                 </a:solidFill>
                 <a:latin typeface="Neo Sans Arabic"/>
               </a:rPr>
-              <a:t>مُسلَّم جزئياً</a:t>
-            </a:r>
-          </a:p>
-        </p:txBody>
-      </p:sp>
-      <p:sp>
-        <p:nvSpPr>
-          <p:cNvPr id="22" name="Rectangle 21"/>
+              <a:t>0 – 7 أيام</a:t>
+            </a:r>
+          </a:p>
+        </p:txBody>
+      </p:sp>
+      <p:sp>
+        <p:nvSpPr>
+          <p:cNvPr id="23" name="Rectangle 22"/>
           <p:cNvSpPr/>
           <p:nvPr/>
         </p:nvSpPr>
         <p:spPr>
           <a:xfrm>
-            <a:off x="6355080" y="3538728"/>
-            <a:ext cx="3520440" cy="384048"/>
+            <a:off x="457200" y="1783080"/>
+            <a:ext cx="3337560" cy="384048"/>
           </a:xfrm>
           <a:prstGeom prst="rect">
             <a:avLst/>
@@ -24901,14 +24940,180 @@
       </p:sp>
       <p:sp>
         <p:nvSpPr>
-          <p:cNvPr id="23" name="Rectangle 22"/>
+          <p:cNvPr id="24" name="Rectangle 23"/>
           <p:cNvSpPr/>
           <p:nvPr/>
         </p:nvSpPr>
         <p:spPr>
           <a:xfrm>
-            <a:off x="9418320" y="3538728"/>
-            <a:ext cx="457200" cy="384048"/>
+            <a:off x="1569720" y="1783080"/>
+            <a:ext cx="2225040" cy="384048"/>
+          </a:xfrm>
+          <a:prstGeom prst="rect">
+            <a:avLst/>
+          </a:prstGeom>
+          <a:solidFill>
+            <a:srgbClr val="2E6B3E"/>
+          </a:solidFill>
+          <a:ln>
+            <a:noFill/>
+          </a:ln>
+          <a:effectLst/>
+        </p:spPr>
+        <p:style>
+          <a:lnRef idx="1">
+            <a:schemeClr val="accent1"/>
+          </a:lnRef>
+          <a:fillRef idx="3">
+            <a:schemeClr val="accent1"/>
+          </a:fillRef>
+          <a:effectRef idx="2">
+            <a:schemeClr val="accent1"/>
+          </a:effectRef>
+          <a:fontRef idx="minor">
+            <a:schemeClr val="lt1"/>
+          </a:fontRef>
+        </p:style>
+        <p:txBody>
+          <a:bodyPr rtlCol="0" anchor="ctr"/>
+          <a:lstStyle/>
+          <a:p>
+            <a:pPr algn="ctr"/>
+          </a:p>
+        </p:txBody>
+      </p:sp>
+      <p:sp>
+        <p:nvSpPr>
+          <p:cNvPr id="25" name="TextBox 24"/>
+          <p:cNvSpPr txBox="1"/>
+          <p:nvPr/>
+        </p:nvSpPr>
+        <p:spPr>
+          <a:xfrm>
+            <a:off x="1615440" y="1783080"/>
+            <a:ext cx="2133600" cy="384048"/>
+          </a:xfrm>
+          <a:prstGeom prst="rect">
+            <a:avLst/>
+          </a:prstGeom>
+          <a:noFill/>
+        </p:spPr>
+        <p:txBody>
+          <a:bodyPr wrap="square" anchor="ctr" lIns="76200" rIns="76200" tIns="38100" bIns="38100">
+            <a:spAutoFit/>
+          </a:bodyPr>
+          <a:lstStyle/>
+          <a:p>
+            <a:pPr algn="l">
+              <a:spcAft>
+                <a:spcPts val="600"/>
+              </a:spcAft>
+            </a:pPr>
+            <a:r>
+              <a:rPr sz="1400" b="1">
+                <a:solidFill>
+                  <a:srgbClr val="FFFFFF"/>
+                </a:solidFill>
+                <a:latin typeface="Neo Sans Arabic"/>
+              </a:rPr>
+              <a:t>2</a:t>
+            </a:r>
+          </a:p>
+        </p:txBody>
+      </p:sp>
+      <p:sp>
+        <p:nvSpPr>
+          <p:cNvPr id="26" name="TextBox 25"/>
+          <p:cNvSpPr txBox="1"/>
+          <p:nvPr/>
+        </p:nvSpPr>
+        <p:spPr>
+          <a:xfrm>
+            <a:off x="3931920" y="2350008"/>
+            <a:ext cx="1920240" cy="420624"/>
+          </a:xfrm>
+          <a:prstGeom prst="rect">
+            <a:avLst/>
+          </a:prstGeom>
+          <a:noFill/>
+        </p:spPr>
+        <p:txBody>
+          <a:bodyPr wrap="square" anchor="ctr" lIns="76200" rIns="76200" tIns="38100" bIns="38100">
+            <a:spAutoFit/>
+          </a:bodyPr>
+          <a:lstStyle/>
+          <a:p>
+            <a:pPr rtl="1" algn="r">
+              <a:spcAft>
+                <a:spcPts val="600"/>
+              </a:spcAft>
+            </a:pPr>
+            <a:r>
+              <a:rPr sz="1400" b="1">
+                <a:solidFill>
+                  <a:srgbClr val="0E2A38"/>
+                </a:solidFill>
+                <a:latin typeface="Neo Sans Arabic"/>
+              </a:rPr>
+              <a:t>8 – 14 يوم</a:t>
+            </a:r>
+          </a:p>
+        </p:txBody>
+      </p:sp>
+      <p:sp>
+        <p:nvSpPr>
+          <p:cNvPr id="27" name="Rectangle 26"/>
+          <p:cNvSpPr/>
+          <p:nvPr/>
+        </p:nvSpPr>
+        <p:spPr>
+          <a:xfrm>
+            <a:off x="457200" y="2368296"/>
+            <a:ext cx="3337560" cy="384048"/>
+          </a:xfrm>
+          <a:prstGeom prst="rect">
+            <a:avLst/>
+          </a:prstGeom>
+          <a:solidFill>
+            <a:srgbClr val="ECE6DA"/>
+          </a:solidFill>
+          <a:ln>
+            <a:noFill/>
+          </a:ln>
+          <a:effectLst/>
+        </p:spPr>
+        <p:style>
+          <a:lnRef idx="1">
+            <a:schemeClr val="accent1"/>
+          </a:lnRef>
+          <a:fillRef idx="3">
+            <a:schemeClr val="accent1"/>
+          </a:fillRef>
+          <a:effectRef idx="2">
+            <a:schemeClr val="accent1"/>
+          </a:effectRef>
+          <a:fontRef idx="minor">
+            <a:schemeClr val="lt1"/>
+          </a:fontRef>
+        </p:style>
+        <p:txBody>
+          <a:bodyPr rtlCol="0" anchor="ctr"/>
+          <a:lstStyle/>
+          <a:p>
+            <a:pPr algn="ctr"/>
+          </a:p>
+        </p:txBody>
+      </p:sp>
+      <p:sp>
+        <p:nvSpPr>
+          <p:cNvPr id="28" name="Rectangle 27"/>
+          <p:cNvSpPr/>
+          <p:nvPr/>
+        </p:nvSpPr>
+        <p:spPr>
+          <a:xfrm>
+            <a:off x="2682240" y="2368296"/>
+            <a:ext cx="1112520" cy="384048"/>
           </a:xfrm>
           <a:prstGeom prst="rect">
             <a:avLst/>
@@ -24945,14 +25150,14 @@
       </p:sp>
       <p:sp>
         <p:nvSpPr>
-          <p:cNvPr id="24" name="TextBox 23"/>
+          <p:cNvPr id="29" name="TextBox 28"/>
           <p:cNvSpPr txBox="1"/>
           <p:nvPr/>
         </p:nvSpPr>
         <p:spPr>
           <a:xfrm>
-            <a:off x="9464040" y="3538728"/>
-            <a:ext cx="365760" cy="384048"/>
+            <a:off x="2727960" y="2368296"/>
+            <a:ext cx="1021080" cy="384048"/>
           </a:xfrm>
           <a:prstGeom prst="rect">
             <a:avLst/>
@@ -24977,21 +25182,21 @@
                 </a:solidFill>
                 <a:latin typeface="Neo Sans Arabic"/>
               </a:rPr>
-              <a:t>2</a:t>
-            </a:r>
-          </a:p>
-        </p:txBody>
-      </p:sp>
-      <p:sp>
-        <p:nvSpPr>
-          <p:cNvPr id="25" name="TextBox 24"/>
+              <a:t>1</a:t>
+            </a:r>
+          </a:p>
+        </p:txBody>
+      </p:sp>
+      <p:sp>
+        <p:nvSpPr>
+          <p:cNvPr id="30" name="TextBox 29"/>
           <p:cNvSpPr txBox="1"/>
           <p:nvPr/>
         </p:nvSpPr>
         <p:spPr>
           <a:xfrm>
-            <a:off x="10012680" y="4105656"/>
-            <a:ext cx="1737360" cy="420624"/>
+            <a:off x="3931920" y="2935224"/>
+            <a:ext cx="1920240" cy="420624"/>
           </a:xfrm>
           <a:prstGeom prst="rect">
             <a:avLst/>
@@ -25016,21 +25221,21 @@
                 </a:solidFill>
                 <a:latin typeface="Neo Sans Arabic"/>
               </a:rPr>
-              <a:t>قيد التوريد</a:t>
-            </a:r>
-          </a:p>
-        </p:txBody>
-      </p:sp>
-      <p:sp>
-        <p:nvSpPr>
-          <p:cNvPr id="26" name="Rectangle 25"/>
+              <a:t>15 – 30 يوم</a:t>
+            </a:r>
+          </a:p>
+        </p:txBody>
+      </p:sp>
+      <p:sp>
+        <p:nvSpPr>
+          <p:cNvPr id="31" name="Rectangle 30"/>
           <p:cNvSpPr/>
           <p:nvPr/>
         </p:nvSpPr>
         <p:spPr>
           <a:xfrm>
-            <a:off x="6355080" y="4123944"/>
-            <a:ext cx="3520440" cy="384048"/>
+            <a:off x="457200" y="2953512"/>
+            <a:ext cx="3337560" cy="384048"/>
           </a:xfrm>
           <a:prstGeom prst="rect">
             <a:avLst/>
@@ -25067,20 +25272,20 @@
       </p:sp>
       <p:sp>
         <p:nvSpPr>
-          <p:cNvPr id="27" name="Rectangle 26"/>
+          <p:cNvPr id="32" name="Rectangle 31"/>
           <p:cNvSpPr/>
           <p:nvPr/>
         </p:nvSpPr>
         <p:spPr>
           <a:xfrm>
-            <a:off x="9418320" y="4123944"/>
-            <a:ext cx="457200" cy="384048"/>
+            <a:off x="1569720" y="2953512"/>
+            <a:ext cx="2225040" cy="384048"/>
           </a:xfrm>
           <a:prstGeom prst="rect">
             <a:avLst/>
           </a:prstGeom>
           <a:solidFill>
-            <a:srgbClr val="0E2A38"/>
+            <a:srgbClr val="C57A0C"/>
           </a:solidFill>
           <a:ln>
             <a:noFill/>
@@ -25111,14 +25316,14 @@
       </p:sp>
       <p:sp>
         <p:nvSpPr>
-          <p:cNvPr id="28" name="TextBox 27"/>
+          <p:cNvPr id="33" name="TextBox 32"/>
           <p:cNvSpPr txBox="1"/>
           <p:nvPr/>
         </p:nvSpPr>
         <p:spPr>
           <a:xfrm>
-            <a:off x="9464040" y="4123944"/>
-            <a:ext cx="365760" cy="384048"/>
+            <a:off x="1615440" y="2953512"/>
+            <a:ext cx="2133600" cy="384048"/>
           </a:xfrm>
           <a:prstGeom prst="rect">
             <a:avLst/>
@@ -25143,60 +25348,21 @@
                 </a:solidFill>
                 <a:latin typeface="Neo Sans Arabic"/>
               </a:rPr>
-              <a:t>1</a:t>
-            </a:r>
-          </a:p>
-        </p:txBody>
-      </p:sp>
-      <p:sp>
-        <p:nvSpPr>
-          <p:cNvPr id="29" name="TextBox 28"/>
+              <a:t>2</a:t>
+            </a:r>
+          </a:p>
+        </p:txBody>
+      </p:sp>
+      <p:sp>
+        <p:nvSpPr>
+          <p:cNvPr id="34" name="TextBox 33"/>
           <p:cNvSpPr txBox="1"/>
           <p:nvPr/>
         </p:nvSpPr>
         <p:spPr>
           <a:xfrm>
-            <a:off x="457200" y="1234440"/>
-            <a:ext cx="5394960" cy="365760"/>
-          </a:xfrm>
-          <a:prstGeom prst="rect">
-            <a:avLst/>
-          </a:prstGeom>
-          <a:noFill/>
-        </p:spPr>
-        <p:txBody>
-          <a:bodyPr wrap="square" anchor="t" lIns="76200" rIns="76200" tIns="38100" bIns="38100">
-            <a:spAutoFit/>
-          </a:bodyPr>
-          <a:lstStyle/>
-          <a:p>
-            <a:pPr rtl="1" algn="r">
-              <a:spcAft>
-                <a:spcPts val="600"/>
-              </a:spcAft>
-            </a:pPr>
-            <a:r>
-              <a:rPr sz="1600" b="1">
-                <a:solidFill>
-                  <a:srgbClr val="C9A24B"/>
-                </a:solidFill>
-                <a:latin typeface="Neo Sans Arabic"/>
-              </a:rPr>
-              <a:t>حسب الأولوية</a:t>
-            </a:r>
-          </a:p>
-        </p:txBody>
-      </p:sp>
-      <p:sp>
-        <p:nvSpPr>
-          <p:cNvPr id="30" name="TextBox 29"/>
-          <p:cNvSpPr txBox="1"/>
-          <p:nvPr/>
-        </p:nvSpPr>
-        <p:spPr>
-          <a:xfrm>
-            <a:off x="4389120" y="1764792"/>
-            <a:ext cx="1463040" cy="420624"/>
+            <a:off x="3931920" y="3520440"/>
+            <a:ext cx="1920240" cy="420624"/>
           </a:xfrm>
           <a:prstGeom prst="rect">
             <a:avLst/>
@@ -25221,21 +25387,21 @@
                 </a:solidFill>
                 <a:latin typeface="Neo Sans Arabic"/>
               </a:rPr>
-              <a:t>متوسط</a:t>
-            </a:r>
-          </a:p>
-        </p:txBody>
-      </p:sp>
-      <p:sp>
-        <p:nvSpPr>
-          <p:cNvPr id="31" name="Rectangle 30"/>
+              <a:t>أكثر من 30 يوم</a:t>
+            </a:r>
+          </a:p>
+        </p:txBody>
+      </p:sp>
+      <p:sp>
+        <p:nvSpPr>
+          <p:cNvPr id="35" name="Rectangle 34"/>
           <p:cNvSpPr/>
           <p:nvPr/>
         </p:nvSpPr>
         <p:spPr>
           <a:xfrm>
-            <a:off x="457200" y="1783080"/>
-            <a:ext cx="3794760" cy="384048"/>
+            <a:off x="457200" y="3538728"/>
+            <a:ext cx="3337560" cy="384048"/>
           </a:xfrm>
           <a:prstGeom prst="rect">
             <a:avLst/>
@@ -25272,346 +25438,14 @@
       </p:sp>
       <p:sp>
         <p:nvSpPr>
-          <p:cNvPr id="32" name="Rectangle 31"/>
-          <p:cNvSpPr/>
-          <p:nvPr/>
-        </p:nvSpPr>
-        <p:spPr>
-          <a:xfrm>
-            <a:off x="457200" y="1783080"/>
-            <a:ext cx="3794760" cy="384048"/>
-          </a:xfrm>
-          <a:prstGeom prst="rect">
-            <a:avLst/>
-          </a:prstGeom>
-          <a:solidFill>
-            <a:srgbClr val="0E2A38"/>
-          </a:solidFill>
-          <a:ln>
-            <a:noFill/>
-          </a:ln>
-          <a:effectLst/>
-        </p:spPr>
-        <p:style>
-          <a:lnRef idx="1">
-            <a:schemeClr val="accent1"/>
-          </a:lnRef>
-          <a:fillRef idx="3">
-            <a:schemeClr val="accent1"/>
-          </a:fillRef>
-          <a:effectRef idx="2">
-            <a:schemeClr val="accent1"/>
-          </a:effectRef>
-          <a:fontRef idx="minor">
-            <a:schemeClr val="lt1"/>
-          </a:fontRef>
-        </p:style>
-        <p:txBody>
-          <a:bodyPr rtlCol="0" anchor="ctr"/>
-          <a:lstStyle/>
-          <a:p>
-            <a:pPr algn="ctr"/>
-          </a:p>
-        </p:txBody>
-      </p:sp>
-      <p:sp>
-        <p:nvSpPr>
-          <p:cNvPr id="33" name="TextBox 32"/>
-          <p:cNvSpPr txBox="1"/>
-          <p:nvPr/>
-        </p:nvSpPr>
-        <p:spPr>
-          <a:xfrm>
-            <a:off x="502920" y="1783080"/>
-            <a:ext cx="3703320" cy="384048"/>
-          </a:xfrm>
-          <a:prstGeom prst="rect">
-            <a:avLst/>
-          </a:prstGeom>
-          <a:noFill/>
-        </p:spPr>
-        <p:txBody>
-          <a:bodyPr wrap="square" anchor="ctr" lIns="76200" rIns="76200" tIns="38100" bIns="38100">
-            <a:spAutoFit/>
-          </a:bodyPr>
-          <a:lstStyle/>
-          <a:p>
-            <a:pPr algn="l">
-              <a:spcAft>
-                <a:spcPts val="600"/>
-              </a:spcAft>
-            </a:pPr>
-            <a:r>
-              <a:rPr sz="1400" b="1">
-                <a:solidFill>
-                  <a:srgbClr val="FFFFFF"/>
-                </a:solidFill>
-                <a:latin typeface="Neo Sans Arabic"/>
-              </a:rPr>
-              <a:t>22</a:t>
-            </a:r>
-          </a:p>
-        </p:txBody>
-      </p:sp>
-      <p:sp>
-        <p:nvSpPr>
-          <p:cNvPr id="34" name="TextBox 33"/>
-          <p:cNvSpPr txBox="1"/>
-          <p:nvPr/>
-        </p:nvSpPr>
-        <p:spPr>
-          <a:xfrm>
-            <a:off x="4389120" y="2350008"/>
-            <a:ext cx="1463040" cy="420624"/>
-          </a:xfrm>
-          <a:prstGeom prst="rect">
-            <a:avLst/>
-          </a:prstGeom>
-          <a:noFill/>
-        </p:spPr>
-        <p:txBody>
-          <a:bodyPr wrap="square" anchor="ctr" lIns="76200" rIns="76200" tIns="38100" bIns="38100">
-            <a:spAutoFit/>
-          </a:bodyPr>
-          <a:lstStyle/>
-          <a:p>
-            <a:pPr rtl="1" algn="r">
-              <a:spcAft>
-                <a:spcPts val="600"/>
-              </a:spcAft>
-            </a:pPr>
-            <a:r>
-              <a:rPr sz="1400" b="1">
-                <a:solidFill>
-                  <a:srgbClr val="0E2A38"/>
-                </a:solidFill>
-                <a:latin typeface="Neo Sans Arabic"/>
-              </a:rPr>
-              <a:t>عالي</a:t>
-            </a:r>
-          </a:p>
-        </p:txBody>
-      </p:sp>
-      <p:sp>
-        <p:nvSpPr>
-          <p:cNvPr id="35" name="Rectangle 34"/>
-          <p:cNvSpPr/>
-          <p:nvPr/>
-        </p:nvSpPr>
-        <p:spPr>
-          <a:xfrm>
-            <a:off x="457200" y="2368296"/>
-            <a:ext cx="3794760" cy="384048"/>
-          </a:xfrm>
-          <a:prstGeom prst="rect">
-            <a:avLst/>
-          </a:prstGeom>
-          <a:solidFill>
-            <a:srgbClr val="ECE6DA"/>
-          </a:solidFill>
-          <a:ln>
-            <a:noFill/>
-          </a:ln>
-          <a:effectLst/>
-        </p:spPr>
-        <p:style>
-          <a:lnRef idx="1">
-            <a:schemeClr val="accent1"/>
-          </a:lnRef>
-          <a:fillRef idx="3">
-            <a:schemeClr val="accent1"/>
-          </a:fillRef>
-          <a:effectRef idx="2">
-            <a:schemeClr val="accent1"/>
-          </a:effectRef>
-          <a:fontRef idx="minor">
-            <a:schemeClr val="lt1"/>
-          </a:fontRef>
-        </p:style>
-        <p:txBody>
-          <a:bodyPr rtlCol="0" anchor="ctr"/>
-          <a:lstStyle/>
-          <a:p>
-            <a:pPr algn="ctr"/>
-          </a:p>
-        </p:txBody>
-      </p:sp>
-      <p:sp>
-        <p:nvSpPr>
           <p:cNvPr id="36" name="Rectangle 35"/>
           <p:cNvSpPr/>
           <p:nvPr/>
         </p:nvSpPr>
         <p:spPr>
           <a:xfrm>
-            <a:off x="1147157" y="2368296"/>
-            <a:ext cx="3104803" cy="384048"/>
-          </a:xfrm>
-          <a:prstGeom prst="rect">
-            <a:avLst/>
-          </a:prstGeom>
-          <a:solidFill>
-            <a:srgbClr val="C57A0C"/>
-          </a:solidFill>
-          <a:ln>
-            <a:noFill/>
-          </a:ln>
-          <a:effectLst/>
-        </p:spPr>
-        <p:style>
-          <a:lnRef idx="1">
-            <a:schemeClr val="accent1"/>
-          </a:lnRef>
-          <a:fillRef idx="3">
-            <a:schemeClr val="accent1"/>
-          </a:fillRef>
-          <a:effectRef idx="2">
-            <a:schemeClr val="accent1"/>
-          </a:effectRef>
-          <a:fontRef idx="minor">
-            <a:schemeClr val="lt1"/>
-          </a:fontRef>
-        </p:style>
-        <p:txBody>
-          <a:bodyPr rtlCol="0" anchor="ctr"/>
-          <a:lstStyle/>
-          <a:p>
-            <a:pPr algn="ctr"/>
-          </a:p>
-        </p:txBody>
-      </p:sp>
-      <p:sp>
-        <p:nvSpPr>
-          <p:cNvPr id="37" name="TextBox 36"/>
-          <p:cNvSpPr txBox="1"/>
-          <p:nvPr/>
-        </p:nvSpPr>
-        <p:spPr>
-          <a:xfrm>
-            <a:off x="1192877" y="2368296"/>
-            <a:ext cx="3013363" cy="384048"/>
-          </a:xfrm>
-          <a:prstGeom prst="rect">
-            <a:avLst/>
-          </a:prstGeom>
-          <a:noFill/>
-        </p:spPr>
-        <p:txBody>
-          <a:bodyPr wrap="square" anchor="ctr" lIns="76200" rIns="76200" tIns="38100" bIns="38100">
-            <a:spAutoFit/>
-          </a:bodyPr>
-          <a:lstStyle/>
-          <a:p>
-            <a:pPr algn="l">
-              <a:spcAft>
-                <a:spcPts val="600"/>
-              </a:spcAft>
-            </a:pPr>
-            <a:r>
-              <a:rPr sz="1400" b="1">
-                <a:solidFill>
-                  <a:srgbClr val="FFFFFF"/>
-                </a:solidFill>
-                <a:latin typeface="Neo Sans Arabic"/>
-              </a:rPr>
-              <a:t>18</a:t>
-            </a:r>
-          </a:p>
-        </p:txBody>
-      </p:sp>
-      <p:sp>
-        <p:nvSpPr>
-          <p:cNvPr id="38" name="TextBox 37"/>
-          <p:cNvSpPr txBox="1"/>
-          <p:nvPr/>
-        </p:nvSpPr>
-        <p:spPr>
-          <a:xfrm>
-            <a:off x="4389120" y="2935224"/>
-            <a:ext cx="1463040" cy="420624"/>
-          </a:xfrm>
-          <a:prstGeom prst="rect">
-            <a:avLst/>
-          </a:prstGeom>
-          <a:noFill/>
-        </p:spPr>
-        <p:txBody>
-          <a:bodyPr wrap="square" anchor="ctr" lIns="76200" rIns="76200" tIns="38100" bIns="38100">
-            <a:spAutoFit/>
-          </a:bodyPr>
-          <a:lstStyle/>
-          <a:p>
-            <a:pPr rtl="1" algn="r">
-              <a:spcAft>
-                <a:spcPts val="600"/>
-              </a:spcAft>
-            </a:pPr>
-            <a:r>
-              <a:rPr sz="1400" b="1">
-                <a:solidFill>
-                  <a:srgbClr val="0E2A38"/>
-                </a:solidFill>
-                <a:latin typeface="Neo Sans Arabic"/>
-              </a:rPr>
-              <a:t>عاجل</a:t>
-            </a:r>
-          </a:p>
-        </p:txBody>
-      </p:sp>
-      <p:sp>
-        <p:nvSpPr>
-          <p:cNvPr id="39" name="Rectangle 38"/>
-          <p:cNvSpPr/>
-          <p:nvPr/>
-        </p:nvSpPr>
-        <p:spPr>
-          <a:xfrm>
-            <a:off x="457200" y="2953512"/>
-            <a:ext cx="3794760" cy="384048"/>
-          </a:xfrm>
-          <a:prstGeom prst="rect">
-            <a:avLst/>
-          </a:prstGeom>
-          <a:solidFill>
-            <a:srgbClr val="ECE6DA"/>
-          </a:solidFill>
-          <a:ln>
-            <a:noFill/>
-          </a:ln>
-          <a:effectLst/>
-        </p:spPr>
-        <p:style>
-          <a:lnRef idx="1">
-            <a:schemeClr val="accent1"/>
-          </a:lnRef>
-          <a:fillRef idx="3">
-            <a:schemeClr val="accent1"/>
-          </a:fillRef>
-          <a:effectRef idx="2">
-            <a:schemeClr val="accent1"/>
-          </a:effectRef>
-          <a:fontRef idx="minor">
-            <a:schemeClr val="lt1"/>
-          </a:fontRef>
-        </p:style>
-        <p:txBody>
-          <a:bodyPr rtlCol="0" anchor="ctr"/>
-          <a:lstStyle/>
-          <a:p>
-            <a:pPr algn="ctr"/>
-          </a:p>
-        </p:txBody>
-      </p:sp>
-      <p:sp>
-        <p:nvSpPr>
-          <p:cNvPr id="40" name="Rectangle 39"/>
-          <p:cNvSpPr/>
-          <p:nvPr/>
-        </p:nvSpPr>
-        <p:spPr>
-          <a:xfrm>
-            <a:off x="2009602" y="2953512"/>
-            <a:ext cx="2242358" cy="384048"/>
+            <a:off x="457200" y="3538728"/>
+            <a:ext cx="3337560" cy="384048"/>
           </a:xfrm>
           <a:prstGeom prst="rect">
             <a:avLst/>
@@ -25648,14 +25482,14 @@
       </p:sp>
       <p:sp>
         <p:nvSpPr>
-          <p:cNvPr id="41" name="TextBox 40"/>
+          <p:cNvPr id="37" name="TextBox 36"/>
           <p:cNvSpPr txBox="1"/>
           <p:nvPr/>
         </p:nvSpPr>
         <p:spPr>
           <a:xfrm>
-            <a:off x="2055322" y="2953512"/>
-            <a:ext cx="2150918" cy="384048"/>
+            <a:off x="502920" y="3538728"/>
+            <a:ext cx="3246120" cy="384048"/>
           </a:xfrm>
           <a:prstGeom prst="rect">
             <a:avLst/>
@@ -25680,21 +25514,21 @@
                 </a:solidFill>
                 <a:latin typeface="Neo Sans Arabic"/>
               </a:rPr>
-              <a:t>13</a:t>
-            </a:r>
-          </a:p>
-        </p:txBody>
-      </p:sp>
-      <p:sp>
-        <p:nvSpPr>
-          <p:cNvPr id="42" name="Rectangle 41"/>
+              <a:t>3</a:t>
+            </a:r>
+          </a:p>
+        </p:txBody>
+      </p:sp>
+      <p:sp>
+        <p:nvSpPr>
+          <p:cNvPr id="38" name="Rectangle 37"/>
           <p:cNvSpPr/>
           <p:nvPr/>
         </p:nvSpPr>
         <p:spPr>
           <a:xfrm>
-            <a:off x="457200" y="3657600"/>
-            <a:ext cx="5394960" cy="1234440"/>
+            <a:off x="457200" y="3977639"/>
+            <a:ext cx="5394960" cy="914400"/>
           </a:xfrm>
           <a:prstGeom prst="rect">
             <a:avLst/>
@@ -25733,14 +25567,14 @@
       </p:sp>
       <p:sp>
         <p:nvSpPr>
-          <p:cNvPr id="43" name="TextBox 42"/>
+          <p:cNvPr id="39" name="TextBox 38"/>
           <p:cNvSpPr txBox="1"/>
           <p:nvPr/>
         </p:nvSpPr>
         <p:spPr>
           <a:xfrm>
-            <a:off x="640080" y="3794760"/>
-            <a:ext cx="5029200" cy="1005840"/>
+            <a:off x="640080" y="4078224"/>
+            <a:ext cx="5029200" cy="731520"/>
           </a:xfrm>
           <a:prstGeom prst="rect">
             <a:avLst/>
@@ -25765,7 +25599,7 @@
                 </a:solidFill>
                 <a:latin typeface="Neo Sans Arabic"/>
               </a:rPr>
-              <a:t>مفارقة «العاجل»</a:t>
+              <a:t>تأخير متفاقم</a:t>
             </a:r>
           </a:p>
           <a:p>
@@ -25781,14 +25615,14 @@
                 </a:solidFill>
                 <a:latin typeface="Neo Sans Arabic"/>
               </a:rPr>
-              <a:t>من 13 طلباً «عاجلاً»: تأخّر 8 وأُلغي 1 — أي أن صفة العاجل لا تضمن السرعة.</a:t>
-            </a:r>
-          </a:p>
-        </p:txBody>
-      </p:sp>
-      <p:sp>
-        <p:nvSpPr>
-          <p:cNvPr id="44" name="Rectangle 43"/>
+              <a:t>من 8 أوامر متأخرة: 5 تجاوزت 15 يوماً، و3 منها أكثر من 30 يوماً.</a:t>
+            </a:r>
+          </a:p>
+        </p:txBody>
+      </p:sp>
+      <p:sp>
+        <p:nvSpPr>
+          <p:cNvPr id="40" name="Rectangle 39"/>
           <p:cNvSpPr/>
           <p:nvPr/>
         </p:nvSpPr>
@@ -25832,7 +25666,7 @@
       </p:sp>
       <p:sp>
         <p:nvSpPr>
-          <p:cNvPr id="45" name="Rectangle 44"/>
+          <p:cNvPr id="41" name="Rectangle 40"/>
           <p:cNvSpPr/>
           <p:nvPr/>
         </p:nvSpPr>
@@ -25876,7 +25710,7 @@
       </p:sp>
       <p:sp>
         <p:nvSpPr>
-          <p:cNvPr id="46" name="TextBox 45"/>
+          <p:cNvPr id="42" name="TextBox 41"/>
           <p:cNvSpPr txBox="1"/>
           <p:nvPr/>
         </p:nvSpPr>
@@ -25924,14 +25758,14 @@
                 </a:solidFill>
                 <a:latin typeface="Neo Sans Arabic"/>
               </a:rPr>
-              <a:t>12 طلباً لم تكتمل (ملغاة/قيد المراجعة)، وثلثا الأوامر متأخرة — مؤشر على خلل في الدورة.</a:t>
-            </a:r>
-          </a:p>
-        </p:txBody>
-      </p:sp>
-      <p:sp>
-        <p:nvSpPr>
-          <p:cNvPr id="47" name="TextBox 46"/>
+              <a:t>لم يُسلَّم في موعده سوى 26.2٪ من الأوامر، و10 أوامر عالقة لدى المالية — خلل في زمن الدورة.</a:t>
+            </a:r>
+          </a:p>
+        </p:txBody>
+      </p:sp>
+      <p:sp>
+        <p:nvSpPr>
+          <p:cNvPr id="43" name="TextBox 42"/>
           <p:cNvSpPr txBox="1"/>
           <p:nvPr/>
         </p:nvSpPr>
@@ -25963,14 +25797,14 @@
                 </a:solidFill>
                 <a:latin typeface="Neo Sans Arabic"/>
               </a:rPr>
-              <a:t>المصدر: نظام المشتريات — سجل أوامر الشراء (53 أمراً)</a:t>
-            </a:r>
-          </a:p>
-        </p:txBody>
-      </p:sp>
-      <p:sp>
-        <p:nvSpPr>
-          <p:cNvPr id="48" name="TextBox 47"/>
+              <a:t>المصدر: نظام المشتريات — سجل أوامر الشراء (57 أمراً)</a:t>
+            </a:r>
+          </a:p>
+        </p:txBody>
+      </p:sp>
+      <p:sp>
+        <p:nvSpPr>
+          <p:cNvPr id="44" name="TextBox 43"/>
           <p:cNvSpPr txBox="1"/>
           <p:nvPr/>
         </p:nvSpPr>
@@ -26230,7 +26064,7 @@
                 </a:solidFill>
                 <a:latin typeface="Neo Sans Arabic"/>
               </a:rPr>
-              <a:t>سبب التأخير الأبرز</a:t>
+              <a:t>مكامن التأخير الأبرز</a:t>
             </a:r>
           </a:p>
         </p:txBody>
@@ -26398,7 +26232,7 @@
                 </a:solidFill>
                 <a:latin typeface="Neo Sans Arabic"/>
               </a:rPr>
-              <a:t>39٪</a:t>
+              <a:t>10</a:t>
             </a:r>
           </a:p>
         </p:txBody>
@@ -26437,7 +26271,7 @@
                 </a:solidFill>
                 <a:latin typeface="Neo Sans Arabic"/>
               </a:rPr>
-              <a:t>من الطلبات المتأخرة</a:t>
+              <a:t>أوامر عالقة لدى المالية</a:t>
             </a:r>
           </a:p>
           <a:p>
@@ -26453,7 +26287,7 @@
                 </a:solidFill>
                 <a:latin typeface="Neo Sans Arabic"/>
               </a:rPr>
-              <a:t>سببها التحويل المالي (14 من 36)</a:t>
+              <a:t>بانتظار التحويل</a:t>
             </a:r>
           </a:p>
         </p:txBody>
@@ -26582,7 +26416,7 @@
                 </a:solidFill>
                 <a:latin typeface="Neo Sans Arabic"/>
               </a:rPr>
-              <a:t>336</a:t>
+              <a:t>20.4</a:t>
             </a:r>
           </a:p>
         </p:txBody>
@@ -26621,7 +26455,7 @@
                 </a:solidFill>
                 <a:latin typeface="Neo Sans Arabic"/>
               </a:rPr>
-              <a:t>يوم تأخير</a:t>
+              <a:t>يوم متوسط التأخير</a:t>
             </a:r>
           </a:p>
           <a:p>
@@ -26637,7 +26471,7 @@
                 </a:solidFill>
                 <a:latin typeface="Neo Sans Arabic"/>
               </a:rPr>
-              <a:t>من أصل 688 بسبب المالية</a:t>
+              <a:t>أقصى 59 يوماً</a:t>
             </a:r>
           </a:p>
         </p:txBody>
@@ -26703,7 +26537,7 @@
             <a:avLst/>
           </a:prstGeom>
           <a:solidFill>
-            <a:srgbClr val="C57A0C"/>
+            <a:srgbClr val="9E2B25"/>
           </a:solidFill>
           <a:ln>
             <a:noFill/>
@@ -26762,11 +26596,11 @@
             <a:r>
               <a:rPr sz="3400" b="1">
                 <a:solidFill>
-                  <a:srgbClr val="C57A0C"/>
-                </a:solidFill>
-                <a:latin typeface="Neo Sans Arabic"/>
-              </a:rPr>
-              <a:t>15.6</a:t>
+                  <a:srgbClr val="9E2B25"/>
+                </a:solidFill>
+                <a:latin typeface="Neo Sans Arabic"/>
+              </a:rPr>
+              <a:t>26.2٪</a:t>
             </a:r>
           </a:p>
         </p:txBody>
@@ -26805,7 +26639,7 @@
                 </a:solidFill>
                 <a:latin typeface="Neo Sans Arabic"/>
               </a:rPr>
-              <a:t>يوم متوسط</a:t>
+              <a:t>سُلّمت في موعدها</a:t>
             </a:r>
           </a:p>
           <a:p>
@@ -26821,7 +26655,7 @@
                 </a:solidFill>
                 <a:latin typeface="Neo Sans Arabic"/>
               </a:rPr>
-              <a:t>زمن التوريد الكلي</a:t>
+              <a:t>11 من 42 مُسلَّماً</a:t>
             </a:r>
           </a:p>
         </p:txBody>
@@ -26860,7 +26694,7 @@
                 </a:solidFill>
                 <a:latin typeface="Neo Sans Arabic"/>
               </a:rPr>
-              <a:t>أوامر الشراء حسب القطاع</a:t>
+              <a:t>أوامر الشراء حسب القطاع (عدداً)</a:t>
             </a:r>
           </a:p>
         </p:txBody>
@@ -27026,7 +26860,7 @@
                 </a:solidFill>
                 <a:latin typeface="Neo Sans Arabic"/>
               </a:rPr>
-              <a:t>27</a:t>
+              <a:t>28</a:t>
             </a:r>
           </a:p>
         </p:txBody>
@@ -27122,8 +26956,8 @@
         </p:nvSpPr>
         <p:spPr>
           <a:xfrm>
-            <a:off x="5105400" y="4343400"/>
-            <a:ext cx="3718560" cy="310896"/>
+            <a:off x="5537019" y="4343400"/>
+            <a:ext cx="3286941" cy="310896"/>
           </a:xfrm>
           <a:prstGeom prst="rect">
             <a:avLst/>
@@ -27166,8 +27000,8 @@
         </p:nvSpPr>
         <p:spPr>
           <a:xfrm>
-            <a:off x="5151120" y="4343400"/>
-            <a:ext cx="3627120" cy="310896"/>
+            <a:off x="5582739" y="4343400"/>
+            <a:ext cx="3195501" cy="310896"/>
           </a:xfrm>
           <a:prstGeom prst="rect">
             <a:avLst/>
@@ -27192,7 +27026,7 @@
                 </a:solidFill>
                 <a:latin typeface="Neo Sans Arabic"/>
               </a:rPr>
-              <a:t>12</a:t>
+              <a:t>11</a:t>
             </a:r>
           </a:p>
         </p:txBody>
@@ -27288,8 +27122,8 @@
         </p:nvSpPr>
         <p:spPr>
           <a:xfrm>
-            <a:off x="6035040" y="4800600"/>
-            <a:ext cx="2788920" cy="310896"/>
+            <a:off x="5835832" y="4800600"/>
+            <a:ext cx="2988128" cy="310896"/>
           </a:xfrm>
           <a:prstGeom prst="rect">
             <a:avLst/>
@@ -27332,8 +27166,8 @@
         </p:nvSpPr>
         <p:spPr>
           <a:xfrm>
-            <a:off x="6080760" y="4800600"/>
-            <a:ext cx="2697480" cy="310896"/>
+            <a:off x="5881552" y="4800600"/>
+            <a:ext cx="2896688" cy="310896"/>
           </a:xfrm>
           <a:prstGeom prst="rect">
             <a:avLst/>
@@ -27358,7 +27192,7 @@
                 </a:solidFill>
                 <a:latin typeface="Neo Sans Arabic"/>
               </a:rPr>
-              <a:t>9</a:t>
+              <a:t>10</a:t>
             </a:r>
           </a:p>
         </p:txBody>
@@ -27454,8 +27288,8 @@
         </p:nvSpPr>
         <p:spPr>
           <a:xfrm>
-            <a:off x="7584440" y="5257800"/>
-            <a:ext cx="1239520" cy="310896"/>
+            <a:off x="7927522" y="5257800"/>
+            <a:ext cx="896438" cy="310896"/>
           </a:xfrm>
           <a:prstGeom prst="rect">
             <a:avLst/>
@@ -27498,8 +27332,8 @@
         </p:nvSpPr>
         <p:spPr>
           <a:xfrm>
-            <a:off x="7630160" y="5257800"/>
-            <a:ext cx="1148080" cy="310896"/>
+            <a:off x="7973242" y="5257800"/>
+            <a:ext cx="804998" cy="310896"/>
           </a:xfrm>
           <a:prstGeom prst="rect">
             <a:avLst/>
@@ -27524,7 +27358,7 @@
                 </a:solidFill>
                 <a:latin typeface="Neo Sans Arabic"/>
               </a:rPr>
-              <a:t>4</a:t>
+              <a:t>3</a:t>
             </a:r>
           </a:p>
         </p:txBody>
@@ -27667,7 +27501,7 @@
                 </a:solidFill>
                 <a:latin typeface="Neo Sans Arabic"/>
               </a:rPr>
-              <a:t>نحو نصف أيام التأخير سببها التحويل المالي — ما يؤكد أولوية إلزام المالية بمدة زمنية.</a:t>
+              <a:t>تتركّز الأوامر في الصيانة والتشغيل (28 من 52)، و10 عالقة لدى المالية — أولوية: إلزام المالية بمدة التحويل.</a:t>
             </a:r>
           </a:p>
         </p:txBody>
@@ -27706,7 +27540,7 @@
                 </a:solidFill>
                 <a:latin typeface="Neo Sans Arabic"/>
               </a:rPr>
-              <a:t>المصدر: نظام المشتريات — سجل أوامر الشراء (53 أمراً)</a:t>
+              <a:t>المصدر: نظام المشتريات — سجل أوامر الشراء (57 أمراً)</a:t>
             </a:r>
           </a:p>
         </p:txBody>

</xml_diff>

<commit_message>
Expand KPIs (add cancelled%, suppliers, cycle-time) instead of replacing; keep live current values and targets
</commit_message>
<xml_diff>
--- a/docs/procurement-executive-deck.pptx
+++ b/docs/procurement-executive-deck.pptx
@@ -16455,8 +16455,8 @@
         </p:nvSpPr>
         <p:spPr>
           <a:xfrm>
-            <a:off x="8127796" y="1508760"/>
-            <a:ext cx="3698138" cy="1691640"/>
+            <a:off x="8127796" y="1298448"/>
+            <a:ext cx="3698138" cy="1417320"/>
           </a:xfrm>
           <a:prstGeom prst="rect">
             <a:avLst/>
@@ -16501,8 +16501,8 @@
         </p:nvSpPr>
         <p:spPr>
           <a:xfrm>
-            <a:off x="8127796" y="1508760"/>
-            <a:ext cx="3698138" cy="502920"/>
+            <a:off x="8127796" y="1298448"/>
+            <a:ext cx="3698138" cy="457200"/>
           </a:xfrm>
           <a:prstGeom prst="rect">
             <a:avLst/>
@@ -16545,8 +16545,8 @@
         </p:nvSpPr>
         <p:spPr>
           <a:xfrm>
-            <a:off x="8127796" y="1508760"/>
-            <a:ext cx="3698138" cy="502920"/>
+            <a:off x="8127796" y="1298448"/>
+            <a:ext cx="3698138" cy="457200"/>
           </a:xfrm>
           <a:prstGeom prst="rect">
             <a:avLst/>
@@ -16565,7 +16565,7 @@
               </a:spcAft>
             </a:pPr>
             <a:r>
-              <a:rPr sz="1500" b="1">
+              <a:rPr sz="1400" b="1">
                 <a:solidFill>
                   <a:srgbClr val="FFFFFF"/>
                 </a:solidFill>
@@ -16584,8 +16584,8 @@
         </p:nvSpPr>
         <p:spPr>
           <a:xfrm>
-            <a:off x="9976865" y="2075688"/>
-            <a:ext cx="1849069" cy="1051560"/>
+            <a:off x="9976865" y="1801368"/>
+            <a:ext cx="1849069" cy="868680"/>
           </a:xfrm>
           <a:prstGeom prst="rect">
             <a:avLst/>
@@ -16600,11 +16600,11 @@
           <a:p>
             <a:pPr rtl="1" algn="ctr">
               <a:spcAft>
-                <a:spcPts val="300"/>
-              </a:spcAft>
-            </a:pPr>
-            <a:r>
-              <a:rPr sz="1100" b="1">
+                <a:spcPts val="200"/>
+              </a:spcAft>
+            </a:pPr>
+            <a:r>
+              <a:rPr sz="1050" b="1">
                 <a:solidFill>
                   <a:srgbClr val="6B747C"/>
                 </a:solidFill>
@@ -16620,7 +16620,7 @@
               </a:spcAft>
             </a:pPr>
             <a:r>
-              <a:rPr sz="1900" b="1">
+              <a:rPr sz="1700" b="1">
                 <a:solidFill>
                   <a:srgbClr val="9E2B25"/>
                 </a:solidFill>
@@ -16639,8 +16639,8 @@
         </p:nvSpPr>
         <p:spPr>
           <a:xfrm>
-            <a:off x="8127796" y="2075688"/>
-            <a:ext cx="1849069" cy="1051560"/>
+            <a:off x="8127796" y="1801368"/>
+            <a:ext cx="1849069" cy="868680"/>
           </a:xfrm>
           <a:prstGeom prst="rect">
             <a:avLst/>
@@ -16655,11 +16655,11 @@
           <a:p>
             <a:pPr rtl="1" algn="ctr">
               <a:spcAft>
-                <a:spcPts val="300"/>
-              </a:spcAft>
-            </a:pPr>
-            <a:r>
-              <a:rPr sz="1100" b="1">
+                <a:spcPts val="200"/>
+              </a:spcAft>
+            </a:pPr>
+            <a:r>
+              <a:rPr sz="1050" b="1">
                 <a:solidFill>
                   <a:srgbClr val="6B747C"/>
                 </a:solidFill>
@@ -16675,7 +16675,7 @@
               </a:spcAft>
             </a:pPr>
             <a:r>
-              <a:rPr sz="1900" b="1">
+              <a:rPr sz="1700" b="1">
                 <a:solidFill>
                   <a:srgbClr val="2E6B3E"/>
                 </a:solidFill>
@@ -16694,8 +16694,8 @@
         </p:nvSpPr>
         <p:spPr>
           <a:xfrm>
-            <a:off x="9867137" y="2194560"/>
-            <a:ext cx="219456" cy="822960"/>
+            <a:off x="9867137" y="1892808"/>
+            <a:ext cx="219456" cy="731520"/>
           </a:xfrm>
           <a:prstGeom prst="rect">
             <a:avLst/>
@@ -16714,7 +16714,7 @@
               </a:spcAft>
             </a:pPr>
             <a:r>
-              <a:rPr sz="2000" b="1">
+              <a:rPr sz="1800" b="1">
                 <a:solidFill>
                   <a:srgbClr val="C9A24B"/>
                 </a:solidFill>
@@ -16733,8 +16733,8 @@
         </p:nvSpPr>
         <p:spPr>
           <a:xfrm>
-            <a:off x="4338218" y="1508760"/>
-            <a:ext cx="3698138" cy="1691640"/>
+            <a:off x="4338218" y="1298448"/>
+            <a:ext cx="3698138" cy="1417320"/>
           </a:xfrm>
           <a:prstGeom prst="rect">
             <a:avLst/>
@@ -16779,8 +16779,8 @@
         </p:nvSpPr>
         <p:spPr>
           <a:xfrm>
-            <a:off x="4338218" y="1508760"/>
-            <a:ext cx="3698138" cy="502920"/>
+            <a:off x="4338218" y="1298448"/>
+            <a:ext cx="3698138" cy="457200"/>
           </a:xfrm>
           <a:prstGeom prst="rect">
             <a:avLst/>
@@ -16823,8 +16823,8 @@
         </p:nvSpPr>
         <p:spPr>
           <a:xfrm>
-            <a:off x="4338218" y="1508760"/>
-            <a:ext cx="3698138" cy="502920"/>
+            <a:off x="4338218" y="1298448"/>
+            <a:ext cx="3698138" cy="457200"/>
           </a:xfrm>
           <a:prstGeom prst="rect">
             <a:avLst/>
@@ -16843,7 +16843,7 @@
               </a:spcAft>
             </a:pPr>
             <a:r>
-              <a:rPr sz="1500" b="1">
+              <a:rPr sz="1400" b="1">
                 <a:solidFill>
                   <a:srgbClr val="FFFFFF"/>
                 </a:solidFill>
@@ -16862,8 +16862,8 @@
         </p:nvSpPr>
         <p:spPr>
           <a:xfrm>
-            <a:off x="6187287" y="2075688"/>
-            <a:ext cx="1849069" cy="1051560"/>
+            <a:off x="6187287" y="1801368"/>
+            <a:ext cx="1849069" cy="868680"/>
           </a:xfrm>
           <a:prstGeom prst="rect">
             <a:avLst/>
@@ -16878,11 +16878,11 @@
           <a:p>
             <a:pPr rtl="1" algn="ctr">
               <a:spcAft>
-                <a:spcPts val="300"/>
-              </a:spcAft>
-            </a:pPr>
-            <a:r>
-              <a:rPr sz="1100" b="1">
+                <a:spcPts val="200"/>
+              </a:spcAft>
+            </a:pPr>
+            <a:r>
+              <a:rPr sz="1050" b="1">
                 <a:solidFill>
                   <a:srgbClr val="6B747C"/>
                 </a:solidFill>
@@ -16898,7 +16898,7 @@
               </a:spcAft>
             </a:pPr>
             <a:r>
-              <a:rPr sz="1900" b="1">
+              <a:rPr sz="1700" b="1">
                 <a:solidFill>
                   <a:srgbClr val="9E2B25"/>
                 </a:solidFill>
@@ -16917,8 +16917,8 @@
         </p:nvSpPr>
         <p:spPr>
           <a:xfrm>
-            <a:off x="4338218" y="2075688"/>
-            <a:ext cx="1849069" cy="1051560"/>
+            <a:off x="4338218" y="1801368"/>
+            <a:ext cx="1849069" cy="868680"/>
           </a:xfrm>
           <a:prstGeom prst="rect">
             <a:avLst/>
@@ -16933,11 +16933,11 @@
           <a:p>
             <a:pPr rtl="1" algn="ctr">
               <a:spcAft>
-                <a:spcPts val="300"/>
-              </a:spcAft>
-            </a:pPr>
-            <a:r>
-              <a:rPr sz="1100" b="1">
+                <a:spcPts val="200"/>
+              </a:spcAft>
+            </a:pPr>
+            <a:r>
+              <a:rPr sz="1050" b="1">
                 <a:solidFill>
                   <a:srgbClr val="6B747C"/>
                 </a:solidFill>
@@ -16953,7 +16953,7 @@
               </a:spcAft>
             </a:pPr>
             <a:r>
-              <a:rPr sz="1900" b="1">
+              <a:rPr sz="1700" b="1">
                 <a:solidFill>
                   <a:srgbClr val="2E6B3E"/>
                 </a:solidFill>
@@ -16972,8 +16972,8 @@
         </p:nvSpPr>
         <p:spPr>
           <a:xfrm>
-            <a:off x="6077559" y="2194560"/>
-            <a:ext cx="219456" cy="822960"/>
+            <a:off x="6077559" y="1892808"/>
+            <a:ext cx="219456" cy="731520"/>
           </a:xfrm>
           <a:prstGeom prst="rect">
             <a:avLst/>
@@ -16992,7 +16992,7 @@
               </a:spcAft>
             </a:pPr>
             <a:r>
-              <a:rPr sz="2000" b="1">
+              <a:rPr sz="1800" b="1">
                 <a:solidFill>
                   <a:srgbClr val="C9A24B"/>
                 </a:solidFill>
@@ -17011,8 +17011,8 @@
         </p:nvSpPr>
         <p:spPr>
           <a:xfrm>
-            <a:off x="548640" y="1508760"/>
-            <a:ext cx="3698138" cy="1691640"/>
+            <a:off x="548640" y="1298448"/>
+            <a:ext cx="3698138" cy="1417320"/>
           </a:xfrm>
           <a:prstGeom prst="rect">
             <a:avLst/>
@@ -17057,8 +17057,8 @@
         </p:nvSpPr>
         <p:spPr>
           <a:xfrm>
-            <a:off x="548640" y="1508760"/>
-            <a:ext cx="3698138" cy="502920"/>
+            <a:off x="548640" y="1298448"/>
+            <a:ext cx="3698138" cy="457200"/>
           </a:xfrm>
           <a:prstGeom prst="rect">
             <a:avLst/>
@@ -17101,8 +17101,8 @@
         </p:nvSpPr>
         <p:spPr>
           <a:xfrm>
-            <a:off x="548640" y="1508760"/>
-            <a:ext cx="3698138" cy="502920"/>
+            <a:off x="548640" y="1298448"/>
+            <a:ext cx="3698138" cy="457200"/>
           </a:xfrm>
           <a:prstGeom prst="rect">
             <a:avLst/>
@@ -17121,7 +17121,7 @@
               </a:spcAft>
             </a:pPr>
             <a:r>
-              <a:rPr sz="1500" b="1">
+              <a:rPr sz="1400" b="1">
                 <a:solidFill>
                   <a:srgbClr val="FFFFFF"/>
                 </a:solidFill>
@@ -17140,8 +17140,8 @@
         </p:nvSpPr>
         <p:spPr>
           <a:xfrm>
-            <a:off x="2397709" y="2075688"/>
-            <a:ext cx="1849069" cy="1051560"/>
+            <a:off x="2397709" y="1801368"/>
+            <a:ext cx="1849069" cy="868680"/>
           </a:xfrm>
           <a:prstGeom prst="rect">
             <a:avLst/>
@@ -17156,11 +17156,11 @@
           <a:p>
             <a:pPr rtl="1" algn="ctr">
               <a:spcAft>
-                <a:spcPts val="300"/>
-              </a:spcAft>
-            </a:pPr>
-            <a:r>
-              <a:rPr sz="1100" b="1">
+                <a:spcPts val="200"/>
+              </a:spcAft>
+            </a:pPr>
+            <a:r>
+              <a:rPr sz="1050" b="1">
                 <a:solidFill>
                   <a:srgbClr val="6B747C"/>
                 </a:solidFill>
@@ -17176,7 +17176,7 @@
               </a:spcAft>
             </a:pPr>
             <a:r>
-              <a:rPr sz="1900" b="1">
+              <a:rPr sz="1700" b="1">
                 <a:solidFill>
                   <a:srgbClr val="9E2B25"/>
                 </a:solidFill>
@@ -17195,8 +17195,8 @@
         </p:nvSpPr>
         <p:spPr>
           <a:xfrm>
-            <a:off x="548640" y="2075688"/>
-            <a:ext cx="1849069" cy="1051560"/>
+            <a:off x="548640" y="1801368"/>
+            <a:ext cx="1849069" cy="868680"/>
           </a:xfrm>
           <a:prstGeom prst="rect">
             <a:avLst/>
@@ -17211,11 +17211,11 @@
           <a:p>
             <a:pPr rtl="1" algn="ctr">
               <a:spcAft>
-                <a:spcPts val="300"/>
-              </a:spcAft>
-            </a:pPr>
-            <a:r>
-              <a:rPr sz="1100" b="1">
+                <a:spcPts val="200"/>
+              </a:spcAft>
+            </a:pPr>
+            <a:r>
+              <a:rPr sz="1050" b="1">
                 <a:solidFill>
                   <a:srgbClr val="6B747C"/>
                 </a:solidFill>
@@ -17231,7 +17231,7 @@
               </a:spcAft>
             </a:pPr>
             <a:r>
-              <a:rPr sz="1900" b="1">
+              <a:rPr sz="1700" b="1">
                 <a:solidFill>
                   <a:srgbClr val="2E6B3E"/>
                 </a:solidFill>
@@ -17250,8 +17250,8 @@
         </p:nvSpPr>
         <p:spPr>
           <a:xfrm>
-            <a:off x="2287981" y="2194560"/>
-            <a:ext cx="219456" cy="822960"/>
+            <a:off x="2287981" y="1892808"/>
+            <a:ext cx="219456" cy="731520"/>
           </a:xfrm>
           <a:prstGeom prst="rect">
             <a:avLst/>
@@ -17270,7 +17270,7 @@
               </a:spcAft>
             </a:pPr>
             <a:r>
-              <a:rPr sz="2000" b="1">
+              <a:rPr sz="1800" b="1">
                 <a:solidFill>
                   <a:srgbClr val="C9A24B"/>
                 </a:solidFill>
@@ -17289,8 +17289,8 @@
         </p:nvSpPr>
         <p:spPr>
           <a:xfrm>
-            <a:off x="8127796" y="3474720"/>
-            <a:ext cx="3698138" cy="1691640"/>
+            <a:off x="8127796" y="2926080"/>
+            <a:ext cx="3698138" cy="1417320"/>
           </a:xfrm>
           <a:prstGeom prst="rect">
             <a:avLst/>
@@ -17335,8 +17335,8 @@
         </p:nvSpPr>
         <p:spPr>
           <a:xfrm>
-            <a:off x="8127796" y="3474720"/>
-            <a:ext cx="3698138" cy="502920"/>
+            <a:off x="8127796" y="2926080"/>
+            <a:ext cx="3698138" cy="457200"/>
           </a:xfrm>
           <a:prstGeom prst="rect">
             <a:avLst/>
@@ -17379,8 +17379,8 @@
         </p:nvSpPr>
         <p:spPr>
           <a:xfrm>
-            <a:off x="8127796" y="3474720"/>
-            <a:ext cx="3698138" cy="502920"/>
+            <a:off x="8127796" y="2926080"/>
+            <a:ext cx="3698138" cy="457200"/>
           </a:xfrm>
           <a:prstGeom prst="rect">
             <a:avLst/>
@@ -17399,7 +17399,7 @@
               </a:spcAft>
             </a:pPr>
             <a:r>
-              <a:rPr sz="1500" b="1">
+              <a:rPr sz="1400" b="1">
                 <a:solidFill>
                   <a:srgbClr val="FFFFFF"/>
                 </a:solidFill>
@@ -17418,8 +17418,8 @@
         </p:nvSpPr>
         <p:spPr>
           <a:xfrm>
-            <a:off x="9976865" y="4041648"/>
-            <a:ext cx="1849069" cy="1051560"/>
+            <a:off x="9976865" y="3429000"/>
+            <a:ext cx="1849069" cy="868680"/>
           </a:xfrm>
           <a:prstGeom prst="rect">
             <a:avLst/>
@@ -17434,11 +17434,11 @@
           <a:p>
             <a:pPr rtl="1" algn="ctr">
               <a:spcAft>
-                <a:spcPts val="300"/>
-              </a:spcAft>
-            </a:pPr>
-            <a:r>
-              <a:rPr sz="1100" b="1">
+                <a:spcPts val="200"/>
+              </a:spcAft>
+            </a:pPr>
+            <a:r>
+              <a:rPr sz="1050" b="1">
                 <a:solidFill>
                   <a:srgbClr val="6B747C"/>
                 </a:solidFill>
@@ -17454,7 +17454,7 @@
               </a:spcAft>
             </a:pPr>
             <a:r>
-              <a:rPr sz="1900" b="1">
+              <a:rPr sz="1700" b="1">
                 <a:solidFill>
                   <a:srgbClr val="9E2B25"/>
                 </a:solidFill>
@@ -17473,8 +17473,8 @@
         </p:nvSpPr>
         <p:spPr>
           <a:xfrm>
-            <a:off x="8127796" y="4041648"/>
-            <a:ext cx="1849069" cy="1051560"/>
+            <a:off x="8127796" y="3429000"/>
+            <a:ext cx="1849069" cy="868680"/>
           </a:xfrm>
           <a:prstGeom prst="rect">
             <a:avLst/>
@@ -17489,11 +17489,11 @@
           <a:p>
             <a:pPr rtl="1" algn="ctr">
               <a:spcAft>
-                <a:spcPts val="300"/>
-              </a:spcAft>
-            </a:pPr>
-            <a:r>
-              <a:rPr sz="1100" b="1">
+                <a:spcPts val="200"/>
+              </a:spcAft>
+            </a:pPr>
+            <a:r>
+              <a:rPr sz="1050" b="1">
                 <a:solidFill>
                   <a:srgbClr val="6B747C"/>
                 </a:solidFill>
@@ -17509,7 +17509,7 @@
               </a:spcAft>
             </a:pPr>
             <a:r>
-              <a:rPr sz="1900" b="1">
+              <a:rPr sz="1700" b="1">
                 <a:solidFill>
                   <a:srgbClr val="2E6B3E"/>
                 </a:solidFill>
@@ -17528,8 +17528,8 @@
         </p:nvSpPr>
         <p:spPr>
           <a:xfrm>
-            <a:off x="9867137" y="4160520"/>
-            <a:ext cx="219456" cy="822960"/>
+            <a:off x="9867137" y="3520440"/>
+            <a:ext cx="219456" cy="731520"/>
           </a:xfrm>
           <a:prstGeom prst="rect">
             <a:avLst/>
@@ -17548,7 +17548,7 @@
               </a:spcAft>
             </a:pPr>
             <a:r>
-              <a:rPr sz="2000" b="1">
+              <a:rPr sz="1800" b="1">
                 <a:solidFill>
                   <a:srgbClr val="C9A24B"/>
                 </a:solidFill>
@@ -17567,8 +17567,8 @@
         </p:nvSpPr>
         <p:spPr>
           <a:xfrm>
-            <a:off x="4338218" y="3474720"/>
-            <a:ext cx="3698138" cy="1691640"/>
+            <a:off x="4338218" y="2926080"/>
+            <a:ext cx="3698138" cy="1417320"/>
           </a:xfrm>
           <a:prstGeom prst="rect">
             <a:avLst/>
@@ -17613,8 +17613,8 @@
         </p:nvSpPr>
         <p:spPr>
           <a:xfrm>
-            <a:off x="4338218" y="3474720"/>
-            <a:ext cx="3698138" cy="502920"/>
+            <a:off x="4338218" y="2926080"/>
+            <a:ext cx="3698138" cy="457200"/>
           </a:xfrm>
           <a:prstGeom prst="rect">
             <a:avLst/>
@@ -17657,8 +17657,8 @@
         </p:nvSpPr>
         <p:spPr>
           <a:xfrm>
-            <a:off x="4338218" y="3474720"/>
-            <a:ext cx="3698138" cy="502920"/>
+            <a:off x="4338218" y="2926080"/>
+            <a:ext cx="3698138" cy="457200"/>
           </a:xfrm>
           <a:prstGeom prst="rect">
             <a:avLst/>
@@ -17677,7 +17677,7 @@
               </a:spcAft>
             </a:pPr>
             <a:r>
-              <a:rPr sz="1500" b="1">
+              <a:rPr sz="1400" b="1">
                 <a:solidFill>
                   <a:srgbClr val="FFFFFF"/>
                 </a:solidFill>
@@ -17696,8 +17696,8 @@
         </p:nvSpPr>
         <p:spPr>
           <a:xfrm>
-            <a:off x="6187287" y="4041648"/>
-            <a:ext cx="1849069" cy="1051560"/>
+            <a:off x="6187287" y="3429000"/>
+            <a:ext cx="1849069" cy="868680"/>
           </a:xfrm>
           <a:prstGeom prst="rect">
             <a:avLst/>
@@ -17712,11 +17712,11 @@
           <a:p>
             <a:pPr rtl="1" algn="ctr">
               <a:spcAft>
-                <a:spcPts val="300"/>
-              </a:spcAft>
-            </a:pPr>
-            <a:r>
-              <a:rPr sz="1100" b="1">
+                <a:spcPts val="200"/>
+              </a:spcAft>
+            </a:pPr>
+            <a:r>
+              <a:rPr sz="1050" b="1">
                 <a:solidFill>
                   <a:srgbClr val="6B747C"/>
                 </a:solidFill>
@@ -17732,7 +17732,7 @@
               </a:spcAft>
             </a:pPr>
             <a:r>
-              <a:rPr sz="1900" b="1">
+              <a:rPr sz="1700" b="1">
                 <a:solidFill>
                   <a:srgbClr val="9E2B25"/>
                 </a:solidFill>
@@ -17751,8 +17751,8 @@
         </p:nvSpPr>
         <p:spPr>
           <a:xfrm>
-            <a:off x="4338218" y="4041648"/>
-            <a:ext cx="1849069" cy="1051560"/>
+            <a:off x="4338218" y="3429000"/>
+            <a:ext cx="1849069" cy="868680"/>
           </a:xfrm>
           <a:prstGeom prst="rect">
             <a:avLst/>
@@ -17767,11 +17767,11 @@
           <a:p>
             <a:pPr rtl="1" algn="ctr">
               <a:spcAft>
-                <a:spcPts val="300"/>
-              </a:spcAft>
-            </a:pPr>
-            <a:r>
-              <a:rPr sz="1100" b="1">
+                <a:spcPts val="200"/>
+              </a:spcAft>
+            </a:pPr>
+            <a:r>
+              <a:rPr sz="1050" b="1">
                 <a:solidFill>
                   <a:srgbClr val="6B747C"/>
                 </a:solidFill>
@@ -17787,7 +17787,7 @@
               </a:spcAft>
             </a:pPr>
             <a:r>
-              <a:rPr sz="1900" b="1">
+              <a:rPr sz="1700" b="1">
                 <a:solidFill>
                   <a:srgbClr val="2E6B3E"/>
                 </a:solidFill>
@@ -17806,8 +17806,8 @@
         </p:nvSpPr>
         <p:spPr>
           <a:xfrm>
-            <a:off x="6077559" y="4160520"/>
-            <a:ext cx="219456" cy="822960"/>
+            <a:off x="6077559" y="3520440"/>
+            <a:ext cx="219456" cy="731520"/>
           </a:xfrm>
           <a:prstGeom prst="rect">
             <a:avLst/>
@@ -17826,7 +17826,7 @@
               </a:spcAft>
             </a:pPr>
             <a:r>
-              <a:rPr sz="2000" b="1">
+              <a:rPr sz="1800" b="1">
                 <a:solidFill>
                   <a:srgbClr val="C9A24B"/>
                 </a:solidFill>
@@ -17845,8 +17845,8 @@
         </p:nvSpPr>
         <p:spPr>
           <a:xfrm>
-            <a:off x="548640" y="3474720"/>
-            <a:ext cx="3698138" cy="1691640"/>
+            <a:off x="548640" y="2926080"/>
+            <a:ext cx="3698138" cy="1417320"/>
           </a:xfrm>
           <a:prstGeom prst="rect">
             <a:avLst/>
@@ -17891,8 +17891,8 @@
         </p:nvSpPr>
         <p:spPr>
           <a:xfrm>
-            <a:off x="548640" y="3474720"/>
-            <a:ext cx="3698138" cy="502920"/>
+            <a:off x="548640" y="2926080"/>
+            <a:ext cx="3698138" cy="457200"/>
           </a:xfrm>
           <a:prstGeom prst="rect">
             <a:avLst/>
@@ -17935,8 +17935,8 @@
         </p:nvSpPr>
         <p:spPr>
           <a:xfrm>
-            <a:off x="548640" y="3474720"/>
-            <a:ext cx="3698138" cy="502920"/>
+            <a:off x="548640" y="2926080"/>
+            <a:ext cx="3698138" cy="457200"/>
           </a:xfrm>
           <a:prstGeom prst="rect">
             <a:avLst/>
@@ -17955,13 +17955,13 @@
               </a:spcAft>
             </a:pPr>
             <a:r>
-              <a:rPr sz="1500" b="1">
+              <a:rPr sz="1400" b="1">
                 <a:solidFill>
                   <a:srgbClr val="FFFFFF"/>
                 </a:solidFill>
                 <a:latin typeface="Neo Sans Arabic"/>
               </a:rPr>
-              <a:t>الالتزام بالعروض الثلاثة</a:t>
+              <a:t>الأوامر الملغاة</a:t>
             </a:r>
           </a:p>
         </p:txBody>
@@ -17974,8 +17974,8 @@
         </p:nvSpPr>
         <p:spPr>
           <a:xfrm>
-            <a:off x="2397709" y="4041648"/>
-            <a:ext cx="1849069" cy="1051560"/>
+            <a:off x="2397709" y="3429000"/>
+            <a:ext cx="1849069" cy="868680"/>
           </a:xfrm>
           <a:prstGeom prst="rect">
             <a:avLst/>
@@ -17990,11 +17990,11 @@
           <a:p>
             <a:pPr rtl="1" algn="ctr">
               <a:spcAft>
-                <a:spcPts val="300"/>
-              </a:spcAft>
-            </a:pPr>
-            <a:r>
-              <a:rPr sz="1100" b="1">
+                <a:spcPts val="200"/>
+              </a:spcAft>
+            </a:pPr>
+            <a:r>
+              <a:rPr sz="1050" b="1">
                 <a:solidFill>
                   <a:srgbClr val="6B747C"/>
                 </a:solidFill>
@@ -18010,13 +18010,13 @@
               </a:spcAft>
             </a:pPr>
             <a:r>
-              <a:rPr sz="1900" b="1">
+              <a:rPr sz="1700" b="1">
                 <a:solidFill>
                   <a:srgbClr val="9E2B25"/>
                 </a:solidFill>
                 <a:latin typeface="Neo Sans Arabic"/>
               </a:rPr>
-              <a:t>يُبدأ القياس</a:t>
+              <a:t>8.8٪</a:t>
             </a:r>
           </a:p>
         </p:txBody>
@@ -18029,8 +18029,8 @@
         </p:nvSpPr>
         <p:spPr>
           <a:xfrm>
-            <a:off x="548640" y="4041648"/>
-            <a:ext cx="1849069" cy="1051560"/>
+            <a:off x="548640" y="3429000"/>
+            <a:ext cx="1849069" cy="868680"/>
           </a:xfrm>
           <a:prstGeom prst="rect">
             <a:avLst/>
@@ -18045,11 +18045,11 @@
           <a:p>
             <a:pPr rtl="1" algn="ctr">
               <a:spcAft>
-                <a:spcPts val="300"/>
-              </a:spcAft>
-            </a:pPr>
-            <a:r>
-              <a:rPr sz="1100" b="1">
+                <a:spcPts val="200"/>
+              </a:spcAft>
+            </a:pPr>
+            <a:r>
+              <a:rPr sz="1050" b="1">
                 <a:solidFill>
                   <a:srgbClr val="6B747C"/>
                 </a:solidFill>
@@ -18065,13 +18065,13 @@
               </a:spcAft>
             </a:pPr>
             <a:r>
-              <a:rPr sz="1900" b="1">
+              <a:rPr sz="1700" b="1">
                 <a:solidFill>
                   <a:srgbClr val="2E6B3E"/>
                 </a:solidFill>
                 <a:latin typeface="Neo Sans Arabic"/>
               </a:rPr>
-              <a:t>95٪ فأكثر</a:t>
+              <a:t>أقل من 3٪</a:t>
             </a:r>
           </a:p>
         </p:txBody>
@@ -18084,8 +18084,8 @@
         </p:nvSpPr>
         <p:spPr>
           <a:xfrm>
-            <a:off x="2287981" y="4160520"/>
-            <a:ext cx="219456" cy="822960"/>
+            <a:off x="2287981" y="3520440"/>
+            <a:ext cx="219456" cy="731520"/>
           </a:xfrm>
           <a:prstGeom prst="rect">
             <a:avLst/>
@@ -18104,7 +18104,7 @@
               </a:spcAft>
             </a:pPr>
             <a:r>
-              <a:rPr sz="2000" b="1">
+              <a:rPr sz="1800" b="1">
                 <a:solidFill>
                   <a:srgbClr val="C9A24B"/>
                 </a:solidFill>
@@ -18117,7 +18117,841 @@
       </p:sp>
       <p:sp>
         <p:nvSpPr>
-          <p:cNvPr id="44" name="TextBox 43"/>
+          <p:cNvPr id="44" name="Rectangle 43"/>
+          <p:cNvSpPr/>
+          <p:nvPr/>
+        </p:nvSpPr>
+        <p:spPr>
+          <a:xfrm>
+            <a:off x="8127796" y="4553712"/>
+            <a:ext cx="3698138" cy="1417320"/>
+          </a:xfrm>
+          <a:prstGeom prst="rect">
+            <a:avLst/>
+          </a:prstGeom>
+          <a:solidFill>
+            <a:srgbClr val="FFFFFF"/>
+          </a:solidFill>
+          <a:ln w="12700">
+            <a:solidFill>
+              <a:srgbClr val="DDD4C2"/>
+            </a:solidFill>
+          </a:ln>
+          <a:effectLst/>
+        </p:spPr>
+        <p:style>
+          <a:lnRef idx="1">
+            <a:schemeClr val="accent1"/>
+          </a:lnRef>
+          <a:fillRef idx="3">
+            <a:schemeClr val="accent1"/>
+          </a:fillRef>
+          <a:effectRef idx="2">
+            <a:schemeClr val="accent1"/>
+          </a:effectRef>
+          <a:fontRef idx="minor">
+            <a:schemeClr val="lt1"/>
+          </a:fontRef>
+        </p:style>
+        <p:txBody>
+          <a:bodyPr rtlCol="0" anchor="ctr"/>
+          <a:lstStyle/>
+          <a:p>
+            <a:pPr algn="ctr"/>
+          </a:p>
+        </p:txBody>
+      </p:sp>
+      <p:sp>
+        <p:nvSpPr>
+          <p:cNvPr id="45" name="Rectangle 44"/>
+          <p:cNvSpPr/>
+          <p:nvPr/>
+        </p:nvSpPr>
+        <p:spPr>
+          <a:xfrm>
+            <a:off x="8127796" y="4553712"/>
+            <a:ext cx="3698138" cy="457200"/>
+          </a:xfrm>
+          <a:prstGeom prst="rect">
+            <a:avLst/>
+          </a:prstGeom>
+          <a:solidFill>
+            <a:srgbClr val="0E2A38"/>
+          </a:solidFill>
+          <a:ln>
+            <a:noFill/>
+          </a:ln>
+          <a:effectLst/>
+        </p:spPr>
+        <p:style>
+          <a:lnRef idx="1">
+            <a:schemeClr val="accent1"/>
+          </a:lnRef>
+          <a:fillRef idx="3">
+            <a:schemeClr val="accent1"/>
+          </a:fillRef>
+          <a:effectRef idx="2">
+            <a:schemeClr val="accent1"/>
+          </a:effectRef>
+          <a:fontRef idx="minor">
+            <a:schemeClr val="lt1"/>
+          </a:fontRef>
+        </p:style>
+        <p:txBody>
+          <a:bodyPr rtlCol="0" anchor="ctr"/>
+          <a:lstStyle/>
+          <a:p>
+            <a:pPr algn="ctr"/>
+          </a:p>
+        </p:txBody>
+      </p:sp>
+      <p:sp>
+        <p:nvSpPr>
+          <p:cNvPr id="46" name="TextBox 45"/>
+          <p:cNvSpPr txBox="1"/>
+          <p:nvPr/>
+        </p:nvSpPr>
+        <p:spPr>
+          <a:xfrm>
+            <a:off x="8127796" y="4553712"/>
+            <a:ext cx="3698138" cy="457200"/>
+          </a:xfrm>
+          <a:prstGeom prst="rect">
+            <a:avLst/>
+          </a:prstGeom>
+          <a:noFill/>
+        </p:spPr>
+        <p:txBody>
+          <a:bodyPr wrap="square" anchor="ctr" lIns="76200" rIns="76200" tIns="38100" bIns="38100">
+            <a:spAutoFit/>
+          </a:bodyPr>
+          <a:lstStyle/>
+          <a:p>
+            <a:pPr rtl="1" algn="ctr">
+              <a:spcAft>
+                <a:spcPts val="600"/>
+              </a:spcAft>
+            </a:pPr>
+            <a:r>
+              <a:rPr sz="1400" b="1">
+                <a:solidFill>
+                  <a:srgbClr val="FFFFFF"/>
+                </a:solidFill>
+                <a:latin typeface="Neo Sans Arabic"/>
+              </a:rPr>
+              <a:t>الالتزام بالعروض الثلاثة</a:t>
+            </a:r>
+          </a:p>
+        </p:txBody>
+      </p:sp>
+      <p:sp>
+        <p:nvSpPr>
+          <p:cNvPr id="47" name="TextBox 46"/>
+          <p:cNvSpPr txBox="1"/>
+          <p:nvPr/>
+        </p:nvSpPr>
+        <p:spPr>
+          <a:xfrm>
+            <a:off x="9976865" y="5056632"/>
+            <a:ext cx="1849069" cy="868680"/>
+          </a:xfrm>
+          <a:prstGeom prst="rect">
+            <a:avLst/>
+          </a:prstGeom>
+          <a:noFill/>
+        </p:spPr>
+        <p:txBody>
+          <a:bodyPr wrap="square" anchor="ctr" lIns="76200" rIns="76200" tIns="38100" bIns="38100">
+            <a:spAutoFit/>
+          </a:bodyPr>
+          <a:lstStyle/>
+          <a:p>
+            <a:pPr rtl="1" algn="ctr">
+              <a:spcAft>
+                <a:spcPts val="200"/>
+              </a:spcAft>
+            </a:pPr>
+            <a:r>
+              <a:rPr sz="1050" b="1">
+                <a:solidFill>
+                  <a:srgbClr val="6B747C"/>
+                </a:solidFill>
+                <a:latin typeface="Neo Sans Arabic"/>
+              </a:rPr>
+              <a:t>الحالي</a:t>
+            </a:r>
+          </a:p>
+          <a:p>
+            <a:pPr rtl="1" algn="ctr">
+              <a:spcAft>
+                <a:spcPts val="600"/>
+              </a:spcAft>
+            </a:pPr>
+            <a:r>
+              <a:rPr sz="1700" b="1">
+                <a:solidFill>
+                  <a:srgbClr val="9E2B25"/>
+                </a:solidFill>
+                <a:latin typeface="Neo Sans Arabic"/>
+              </a:rPr>
+              <a:t>يُبدأ القياس</a:t>
+            </a:r>
+          </a:p>
+        </p:txBody>
+      </p:sp>
+      <p:sp>
+        <p:nvSpPr>
+          <p:cNvPr id="48" name="TextBox 47"/>
+          <p:cNvSpPr txBox="1"/>
+          <p:nvPr/>
+        </p:nvSpPr>
+        <p:spPr>
+          <a:xfrm>
+            <a:off x="8127796" y="5056632"/>
+            <a:ext cx="1849069" cy="868680"/>
+          </a:xfrm>
+          <a:prstGeom prst="rect">
+            <a:avLst/>
+          </a:prstGeom>
+          <a:noFill/>
+        </p:spPr>
+        <p:txBody>
+          <a:bodyPr wrap="square" anchor="ctr" lIns="76200" rIns="76200" tIns="38100" bIns="38100">
+            <a:spAutoFit/>
+          </a:bodyPr>
+          <a:lstStyle/>
+          <a:p>
+            <a:pPr rtl="1" algn="ctr">
+              <a:spcAft>
+                <a:spcPts val="200"/>
+              </a:spcAft>
+            </a:pPr>
+            <a:r>
+              <a:rPr sz="1050" b="1">
+                <a:solidFill>
+                  <a:srgbClr val="6B747C"/>
+                </a:solidFill>
+                <a:latin typeface="Neo Sans Arabic"/>
+              </a:rPr>
+              <a:t>الهدف</a:t>
+            </a:r>
+          </a:p>
+          <a:p>
+            <a:pPr rtl="1" algn="ctr">
+              <a:spcAft>
+                <a:spcPts val="600"/>
+              </a:spcAft>
+            </a:pPr>
+            <a:r>
+              <a:rPr sz="1700" b="1">
+                <a:solidFill>
+                  <a:srgbClr val="2E6B3E"/>
+                </a:solidFill>
+                <a:latin typeface="Neo Sans Arabic"/>
+              </a:rPr>
+              <a:t>95٪ فأكثر</a:t>
+            </a:r>
+          </a:p>
+        </p:txBody>
+      </p:sp>
+      <p:sp>
+        <p:nvSpPr>
+          <p:cNvPr id="49" name="TextBox 48"/>
+          <p:cNvSpPr txBox="1"/>
+          <p:nvPr/>
+        </p:nvSpPr>
+        <p:spPr>
+          <a:xfrm>
+            <a:off x="9867137" y="5148072"/>
+            <a:ext cx="219456" cy="731520"/>
+          </a:xfrm>
+          <a:prstGeom prst="rect">
+            <a:avLst/>
+          </a:prstGeom>
+          <a:noFill/>
+        </p:spPr>
+        <p:txBody>
+          <a:bodyPr wrap="square" anchor="ctr" lIns="76200" rIns="76200" tIns="38100" bIns="38100">
+            <a:spAutoFit/>
+          </a:bodyPr>
+          <a:lstStyle/>
+          <a:p>
+            <a:pPr algn="ctr">
+              <a:spcAft>
+                <a:spcPts val="600"/>
+              </a:spcAft>
+            </a:pPr>
+            <a:r>
+              <a:rPr sz="1800" b="1">
+                <a:solidFill>
+                  <a:srgbClr val="C9A24B"/>
+                </a:solidFill>
+                <a:latin typeface="Neo Sans Arabic"/>
+              </a:rPr>
+              <a:t>←</a:t>
+            </a:r>
+          </a:p>
+        </p:txBody>
+      </p:sp>
+      <p:sp>
+        <p:nvSpPr>
+          <p:cNvPr id="50" name="Rectangle 49"/>
+          <p:cNvSpPr/>
+          <p:nvPr/>
+        </p:nvSpPr>
+        <p:spPr>
+          <a:xfrm>
+            <a:off x="4338218" y="4553712"/>
+            <a:ext cx="3698138" cy="1417320"/>
+          </a:xfrm>
+          <a:prstGeom prst="rect">
+            <a:avLst/>
+          </a:prstGeom>
+          <a:solidFill>
+            <a:srgbClr val="FFFFFF"/>
+          </a:solidFill>
+          <a:ln w="12700">
+            <a:solidFill>
+              <a:srgbClr val="DDD4C2"/>
+            </a:solidFill>
+          </a:ln>
+          <a:effectLst/>
+        </p:spPr>
+        <p:style>
+          <a:lnRef idx="1">
+            <a:schemeClr val="accent1"/>
+          </a:lnRef>
+          <a:fillRef idx="3">
+            <a:schemeClr val="accent1"/>
+          </a:fillRef>
+          <a:effectRef idx="2">
+            <a:schemeClr val="accent1"/>
+          </a:effectRef>
+          <a:fontRef idx="minor">
+            <a:schemeClr val="lt1"/>
+          </a:fontRef>
+        </p:style>
+        <p:txBody>
+          <a:bodyPr rtlCol="0" anchor="ctr"/>
+          <a:lstStyle/>
+          <a:p>
+            <a:pPr algn="ctr"/>
+          </a:p>
+        </p:txBody>
+      </p:sp>
+      <p:sp>
+        <p:nvSpPr>
+          <p:cNvPr id="51" name="Rectangle 50"/>
+          <p:cNvSpPr/>
+          <p:nvPr/>
+        </p:nvSpPr>
+        <p:spPr>
+          <a:xfrm>
+            <a:off x="4338218" y="4553712"/>
+            <a:ext cx="3698138" cy="457200"/>
+          </a:xfrm>
+          <a:prstGeom prst="rect">
+            <a:avLst/>
+          </a:prstGeom>
+          <a:solidFill>
+            <a:srgbClr val="0E2A38"/>
+          </a:solidFill>
+          <a:ln>
+            <a:noFill/>
+          </a:ln>
+          <a:effectLst/>
+        </p:spPr>
+        <p:style>
+          <a:lnRef idx="1">
+            <a:schemeClr val="accent1"/>
+          </a:lnRef>
+          <a:fillRef idx="3">
+            <a:schemeClr val="accent1"/>
+          </a:fillRef>
+          <a:effectRef idx="2">
+            <a:schemeClr val="accent1"/>
+          </a:effectRef>
+          <a:fontRef idx="minor">
+            <a:schemeClr val="lt1"/>
+          </a:fontRef>
+        </p:style>
+        <p:txBody>
+          <a:bodyPr rtlCol="0" anchor="ctr"/>
+          <a:lstStyle/>
+          <a:p>
+            <a:pPr algn="ctr"/>
+          </a:p>
+        </p:txBody>
+      </p:sp>
+      <p:sp>
+        <p:nvSpPr>
+          <p:cNvPr id="52" name="TextBox 51"/>
+          <p:cNvSpPr txBox="1"/>
+          <p:nvPr/>
+        </p:nvSpPr>
+        <p:spPr>
+          <a:xfrm>
+            <a:off x="4338218" y="4553712"/>
+            <a:ext cx="3698138" cy="457200"/>
+          </a:xfrm>
+          <a:prstGeom prst="rect">
+            <a:avLst/>
+          </a:prstGeom>
+          <a:noFill/>
+        </p:spPr>
+        <p:txBody>
+          <a:bodyPr wrap="square" anchor="ctr" lIns="76200" rIns="76200" tIns="38100" bIns="38100">
+            <a:spAutoFit/>
+          </a:bodyPr>
+          <a:lstStyle/>
+          <a:p>
+            <a:pPr rtl="1" algn="ctr">
+              <a:spcAft>
+                <a:spcPts val="600"/>
+              </a:spcAft>
+            </a:pPr>
+            <a:r>
+              <a:rPr sz="1400" b="1">
+                <a:solidFill>
+                  <a:srgbClr val="FFFFFF"/>
+                </a:solidFill>
+                <a:latin typeface="Neo Sans Arabic"/>
+              </a:rPr>
+              <a:t>الموردون المعتمدون</a:t>
+            </a:r>
+          </a:p>
+        </p:txBody>
+      </p:sp>
+      <p:sp>
+        <p:nvSpPr>
+          <p:cNvPr id="53" name="TextBox 52"/>
+          <p:cNvSpPr txBox="1"/>
+          <p:nvPr/>
+        </p:nvSpPr>
+        <p:spPr>
+          <a:xfrm>
+            <a:off x="6187287" y="5056632"/>
+            <a:ext cx="1849069" cy="868680"/>
+          </a:xfrm>
+          <a:prstGeom prst="rect">
+            <a:avLst/>
+          </a:prstGeom>
+          <a:noFill/>
+        </p:spPr>
+        <p:txBody>
+          <a:bodyPr wrap="square" anchor="ctr" lIns="76200" rIns="76200" tIns="38100" bIns="38100">
+            <a:spAutoFit/>
+          </a:bodyPr>
+          <a:lstStyle/>
+          <a:p>
+            <a:pPr rtl="1" algn="ctr">
+              <a:spcAft>
+                <a:spcPts val="200"/>
+              </a:spcAft>
+            </a:pPr>
+            <a:r>
+              <a:rPr sz="1050" b="1">
+                <a:solidFill>
+                  <a:srgbClr val="6B747C"/>
+                </a:solidFill>
+                <a:latin typeface="Neo Sans Arabic"/>
+              </a:rPr>
+              <a:t>الحالي</a:t>
+            </a:r>
+          </a:p>
+          <a:p>
+            <a:pPr rtl="1" algn="ctr">
+              <a:spcAft>
+                <a:spcPts val="600"/>
+              </a:spcAft>
+            </a:pPr>
+            <a:r>
+              <a:rPr sz="1700" b="1">
+                <a:solidFill>
+                  <a:srgbClr val="9E2B25"/>
+                </a:solidFill>
+                <a:latin typeface="Neo Sans Arabic"/>
+              </a:rPr>
+              <a:t>53 مورداً</a:t>
+            </a:r>
+          </a:p>
+        </p:txBody>
+      </p:sp>
+      <p:sp>
+        <p:nvSpPr>
+          <p:cNvPr id="54" name="TextBox 53"/>
+          <p:cNvSpPr txBox="1"/>
+          <p:nvPr/>
+        </p:nvSpPr>
+        <p:spPr>
+          <a:xfrm>
+            <a:off x="4338218" y="5056632"/>
+            <a:ext cx="1849069" cy="868680"/>
+          </a:xfrm>
+          <a:prstGeom prst="rect">
+            <a:avLst/>
+          </a:prstGeom>
+          <a:noFill/>
+        </p:spPr>
+        <p:txBody>
+          <a:bodyPr wrap="square" anchor="ctr" lIns="76200" rIns="76200" tIns="38100" bIns="38100">
+            <a:spAutoFit/>
+          </a:bodyPr>
+          <a:lstStyle/>
+          <a:p>
+            <a:pPr rtl="1" algn="ctr">
+              <a:spcAft>
+                <a:spcPts val="200"/>
+              </a:spcAft>
+            </a:pPr>
+            <a:r>
+              <a:rPr sz="1050" b="1">
+                <a:solidFill>
+                  <a:srgbClr val="6B747C"/>
+                </a:solidFill>
+                <a:latin typeface="Neo Sans Arabic"/>
+              </a:rPr>
+              <a:t>الهدف</a:t>
+            </a:r>
+          </a:p>
+          <a:p>
+            <a:pPr rtl="1" algn="ctr">
+              <a:spcAft>
+                <a:spcPts val="600"/>
+              </a:spcAft>
+            </a:pPr>
+            <a:r>
+              <a:rPr sz="1700" b="1">
+                <a:solidFill>
+                  <a:srgbClr val="2E6B3E"/>
+                </a:solidFill>
+                <a:latin typeface="Neo Sans Arabic"/>
+              </a:rPr>
+              <a:t>نموّ مستمر</a:t>
+            </a:r>
+          </a:p>
+        </p:txBody>
+      </p:sp>
+      <p:sp>
+        <p:nvSpPr>
+          <p:cNvPr id="55" name="TextBox 54"/>
+          <p:cNvSpPr txBox="1"/>
+          <p:nvPr/>
+        </p:nvSpPr>
+        <p:spPr>
+          <a:xfrm>
+            <a:off x="6077559" y="5148072"/>
+            <a:ext cx="219456" cy="731520"/>
+          </a:xfrm>
+          <a:prstGeom prst="rect">
+            <a:avLst/>
+          </a:prstGeom>
+          <a:noFill/>
+        </p:spPr>
+        <p:txBody>
+          <a:bodyPr wrap="square" anchor="ctr" lIns="76200" rIns="76200" tIns="38100" bIns="38100">
+            <a:spAutoFit/>
+          </a:bodyPr>
+          <a:lstStyle/>
+          <a:p>
+            <a:pPr algn="ctr">
+              <a:spcAft>
+                <a:spcPts val="600"/>
+              </a:spcAft>
+            </a:pPr>
+            <a:r>
+              <a:rPr sz="1800" b="1">
+                <a:solidFill>
+                  <a:srgbClr val="C9A24B"/>
+                </a:solidFill>
+                <a:latin typeface="Neo Sans Arabic"/>
+              </a:rPr>
+              <a:t>←</a:t>
+            </a:r>
+          </a:p>
+        </p:txBody>
+      </p:sp>
+      <p:sp>
+        <p:nvSpPr>
+          <p:cNvPr id="56" name="Rectangle 55"/>
+          <p:cNvSpPr/>
+          <p:nvPr/>
+        </p:nvSpPr>
+        <p:spPr>
+          <a:xfrm>
+            <a:off x="548640" y="4553712"/>
+            <a:ext cx="3698138" cy="1417320"/>
+          </a:xfrm>
+          <a:prstGeom prst="rect">
+            <a:avLst/>
+          </a:prstGeom>
+          <a:solidFill>
+            <a:srgbClr val="FFFFFF"/>
+          </a:solidFill>
+          <a:ln w="12700">
+            <a:solidFill>
+              <a:srgbClr val="DDD4C2"/>
+            </a:solidFill>
+          </a:ln>
+          <a:effectLst/>
+        </p:spPr>
+        <p:style>
+          <a:lnRef idx="1">
+            <a:schemeClr val="accent1"/>
+          </a:lnRef>
+          <a:fillRef idx="3">
+            <a:schemeClr val="accent1"/>
+          </a:fillRef>
+          <a:effectRef idx="2">
+            <a:schemeClr val="accent1"/>
+          </a:effectRef>
+          <a:fontRef idx="minor">
+            <a:schemeClr val="lt1"/>
+          </a:fontRef>
+        </p:style>
+        <p:txBody>
+          <a:bodyPr rtlCol="0" anchor="ctr"/>
+          <a:lstStyle/>
+          <a:p>
+            <a:pPr algn="ctr"/>
+          </a:p>
+        </p:txBody>
+      </p:sp>
+      <p:sp>
+        <p:nvSpPr>
+          <p:cNvPr id="57" name="Rectangle 56"/>
+          <p:cNvSpPr/>
+          <p:nvPr/>
+        </p:nvSpPr>
+        <p:spPr>
+          <a:xfrm>
+            <a:off x="548640" y="4553712"/>
+            <a:ext cx="3698138" cy="457200"/>
+          </a:xfrm>
+          <a:prstGeom prst="rect">
+            <a:avLst/>
+          </a:prstGeom>
+          <a:solidFill>
+            <a:srgbClr val="0E2A38"/>
+          </a:solidFill>
+          <a:ln>
+            <a:noFill/>
+          </a:ln>
+          <a:effectLst/>
+        </p:spPr>
+        <p:style>
+          <a:lnRef idx="1">
+            <a:schemeClr val="accent1"/>
+          </a:lnRef>
+          <a:fillRef idx="3">
+            <a:schemeClr val="accent1"/>
+          </a:fillRef>
+          <a:effectRef idx="2">
+            <a:schemeClr val="accent1"/>
+          </a:effectRef>
+          <a:fontRef idx="minor">
+            <a:schemeClr val="lt1"/>
+          </a:fontRef>
+        </p:style>
+        <p:txBody>
+          <a:bodyPr rtlCol="0" anchor="ctr"/>
+          <a:lstStyle/>
+          <a:p>
+            <a:pPr algn="ctr"/>
+          </a:p>
+        </p:txBody>
+      </p:sp>
+      <p:sp>
+        <p:nvSpPr>
+          <p:cNvPr id="58" name="TextBox 57"/>
+          <p:cNvSpPr txBox="1"/>
+          <p:nvPr/>
+        </p:nvSpPr>
+        <p:spPr>
+          <a:xfrm>
+            <a:off x="548640" y="4553712"/>
+            <a:ext cx="3698138" cy="457200"/>
+          </a:xfrm>
+          <a:prstGeom prst="rect">
+            <a:avLst/>
+          </a:prstGeom>
+          <a:noFill/>
+        </p:spPr>
+        <p:txBody>
+          <a:bodyPr wrap="square" anchor="ctr" lIns="76200" rIns="76200" tIns="38100" bIns="38100">
+            <a:spAutoFit/>
+          </a:bodyPr>
+          <a:lstStyle/>
+          <a:p>
+            <a:pPr rtl="1" algn="ctr">
+              <a:spcAft>
+                <a:spcPts val="600"/>
+              </a:spcAft>
+            </a:pPr>
+            <a:r>
+              <a:rPr sz="1400" b="1">
+                <a:solidFill>
+                  <a:srgbClr val="FFFFFF"/>
+                </a:solidFill>
+                <a:latin typeface="Neo Sans Arabic"/>
+              </a:rPr>
+              <a:t>زمن دورة الشراء</a:t>
+            </a:r>
+          </a:p>
+        </p:txBody>
+      </p:sp>
+      <p:sp>
+        <p:nvSpPr>
+          <p:cNvPr id="59" name="TextBox 58"/>
+          <p:cNvSpPr txBox="1"/>
+          <p:nvPr/>
+        </p:nvSpPr>
+        <p:spPr>
+          <a:xfrm>
+            <a:off x="2397709" y="5056632"/>
+            <a:ext cx="1849069" cy="868680"/>
+          </a:xfrm>
+          <a:prstGeom prst="rect">
+            <a:avLst/>
+          </a:prstGeom>
+          <a:noFill/>
+        </p:spPr>
+        <p:txBody>
+          <a:bodyPr wrap="square" anchor="ctr" lIns="76200" rIns="76200" tIns="38100" bIns="38100">
+            <a:spAutoFit/>
+          </a:bodyPr>
+          <a:lstStyle/>
+          <a:p>
+            <a:pPr rtl="1" algn="ctr">
+              <a:spcAft>
+                <a:spcPts val="200"/>
+              </a:spcAft>
+            </a:pPr>
+            <a:r>
+              <a:rPr sz="1050" b="1">
+                <a:solidFill>
+                  <a:srgbClr val="6B747C"/>
+                </a:solidFill>
+                <a:latin typeface="Neo Sans Arabic"/>
+              </a:rPr>
+              <a:t>الحالي</a:t>
+            </a:r>
+          </a:p>
+          <a:p>
+            <a:pPr rtl="1" algn="ctr">
+              <a:spcAft>
+                <a:spcPts val="600"/>
+              </a:spcAft>
+            </a:pPr>
+            <a:r>
+              <a:rPr sz="1700" b="1">
+                <a:solidFill>
+                  <a:srgbClr val="9E2B25"/>
+                </a:solidFill>
+                <a:latin typeface="Neo Sans Arabic"/>
+              </a:rPr>
+              <a:t>يُبدأ القياس</a:t>
+            </a:r>
+          </a:p>
+        </p:txBody>
+      </p:sp>
+      <p:sp>
+        <p:nvSpPr>
+          <p:cNvPr id="60" name="TextBox 59"/>
+          <p:cNvSpPr txBox="1"/>
+          <p:nvPr/>
+        </p:nvSpPr>
+        <p:spPr>
+          <a:xfrm>
+            <a:off x="548640" y="5056632"/>
+            <a:ext cx="1849069" cy="868680"/>
+          </a:xfrm>
+          <a:prstGeom prst="rect">
+            <a:avLst/>
+          </a:prstGeom>
+          <a:noFill/>
+        </p:spPr>
+        <p:txBody>
+          <a:bodyPr wrap="square" anchor="ctr" lIns="76200" rIns="76200" tIns="38100" bIns="38100">
+            <a:spAutoFit/>
+          </a:bodyPr>
+          <a:lstStyle/>
+          <a:p>
+            <a:pPr rtl="1" algn="ctr">
+              <a:spcAft>
+                <a:spcPts val="200"/>
+              </a:spcAft>
+            </a:pPr>
+            <a:r>
+              <a:rPr sz="1050" b="1">
+                <a:solidFill>
+                  <a:srgbClr val="6B747C"/>
+                </a:solidFill>
+                <a:latin typeface="Neo Sans Arabic"/>
+              </a:rPr>
+              <a:t>الهدف</a:t>
+            </a:r>
+          </a:p>
+          <a:p>
+            <a:pPr rtl="1" algn="ctr">
+              <a:spcAft>
+                <a:spcPts val="600"/>
+              </a:spcAft>
+            </a:pPr>
+            <a:r>
+              <a:rPr sz="1700" b="1">
+                <a:solidFill>
+                  <a:srgbClr val="2E6B3E"/>
+                </a:solidFill>
+                <a:latin typeface="Neo Sans Arabic"/>
+              </a:rPr>
+              <a:t>ضمن 9 أيام عمل</a:t>
+            </a:r>
+          </a:p>
+        </p:txBody>
+      </p:sp>
+      <p:sp>
+        <p:nvSpPr>
+          <p:cNvPr id="61" name="TextBox 60"/>
+          <p:cNvSpPr txBox="1"/>
+          <p:nvPr/>
+        </p:nvSpPr>
+        <p:spPr>
+          <a:xfrm>
+            <a:off x="2287981" y="5148072"/>
+            <a:ext cx="219456" cy="731520"/>
+          </a:xfrm>
+          <a:prstGeom prst="rect">
+            <a:avLst/>
+          </a:prstGeom>
+          <a:noFill/>
+        </p:spPr>
+        <p:txBody>
+          <a:bodyPr wrap="square" anchor="ctr" lIns="76200" rIns="76200" tIns="38100" bIns="38100">
+            <a:spAutoFit/>
+          </a:bodyPr>
+          <a:lstStyle/>
+          <a:p>
+            <a:pPr algn="ctr">
+              <a:spcAft>
+                <a:spcPts val="600"/>
+              </a:spcAft>
+            </a:pPr>
+            <a:r>
+              <a:rPr sz="1800" b="1">
+                <a:solidFill>
+                  <a:srgbClr val="C9A24B"/>
+                </a:solidFill>
+                <a:latin typeface="Neo Sans Arabic"/>
+              </a:rPr>
+              <a:t>←</a:t>
+            </a:r>
+          </a:p>
+        </p:txBody>
+      </p:sp>
+      <p:sp>
+        <p:nvSpPr>
+          <p:cNvPr id="62" name="TextBox 61"/>
           <p:cNvSpPr txBox="1"/>
           <p:nvPr/>
         </p:nvSpPr>

</xml_diff>